<commit_message>
feat: generate academic project report in PDF, DOCX, and HTML matching Woxsen University template
</commit_message>
<xml_diff>
--- a/SmartRoute_Presentation.pptx
+++ b/SmartRoute_Presentation.pptx
@@ -5,25 +5,25 @@
     <p:sldMasterId id="2147483648" r:id="rId1"/>
   </p:sldMasterIdLst>
   <p:sldIdLst>
-    <p:sldId id="256" r:id="rId7"/>
-    <p:sldId id="257" r:id="rId8"/>
-    <p:sldId id="258" r:id="rId9"/>
-    <p:sldId id="259" r:id="rId10"/>
-    <p:sldId id="260" r:id="rId11"/>
-    <p:sldId id="261" r:id="rId12"/>
-    <p:sldId id="262" r:id="rId13"/>
-    <p:sldId id="263" r:id="rId14"/>
-    <p:sldId id="264" r:id="rId15"/>
-    <p:sldId id="265" r:id="rId16"/>
-    <p:sldId id="266" r:id="rId17"/>
-    <p:sldId id="267" r:id="rId18"/>
-    <p:sldId id="268" r:id="rId19"/>
-    <p:sldId id="269" r:id="rId20"/>
-    <p:sldId id="270" r:id="rId21"/>
-    <p:sldId id="271" r:id="rId22"/>
-    <p:sldId id="272" r:id="rId23"/>
+    <p:sldId id="256" r:id="rId2"/>
+    <p:sldId id="257" r:id="rId3"/>
+    <p:sldId id="258" r:id="rId4"/>
+    <p:sldId id="259" r:id="rId5"/>
+    <p:sldId id="260" r:id="rId6"/>
+    <p:sldId id="261" r:id="rId7"/>
+    <p:sldId id="262" r:id="rId8"/>
+    <p:sldId id="263" r:id="rId9"/>
+    <p:sldId id="264" r:id="rId10"/>
+    <p:sldId id="265" r:id="rId11"/>
+    <p:sldId id="266" r:id="rId12"/>
+    <p:sldId id="267" r:id="rId13"/>
+    <p:sldId id="268" r:id="rId14"/>
+    <p:sldId id="269" r:id="rId15"/>
+    <p:sldId id="270" r:id="rId16"/>
+    <p:sldId id="271" r:id="rId17"/>
+    <p:sldId id="272" r:id="rId18"/>
   </p:sldIdLst>
-  <p:sldSz cx="12191695" cy="6858000" type="screen4x3"/>
+  <p:sldSz cx="12192000" cy="6858000"/>
   <p:notesSz cx="6858000" cy="9144000"/>
   <p:defaultTextStyle>
     <a:defPPr>
@@ -120,6 +120,22 @@
       </a:defRPr>
     </a:lvl9pPr>
   </p:defaultTextStyle>
+  <p:extLst>
+    <p:ext uri="{EFAFB233-063F-42B5-8137-9DF3F51BA10A}">
+      <p15:sldGuideLst xmlns:p15="http://schemas.microsoft.com/office/powerpoint/2012/main">
+        <p15:guide id="1" orient="horz" pos="2160">
+          <p15:clr>
+            <a:srgbClr val="A4A3A4"/>
+          </p15:clr>
+        </p15:guide>
+        <p15:guide id="2" pos="2880">
+          <p15:clr>
+            <a:srgbClr val="A4A3A4"/>
+          </p15:clr>
+        </p15:guide>
+      </p15:sldGuideLst>
+    </p:ext>
+  </p:extLst>
 </p:presentation>
 </file>
 
@@ -161,10 +177,9 @@
           <a:lstStyle/>
           <a:p>
             <a:r>
-              <a:rPr lang="en-US" smtClean="0"/>
+              <a:rPr lang="en-US"/>
               <a:t>Click to edit Master title style</a:t>
             </a:r>
-            <a:endParaRPr lang="en-US"/>
           </a:p>
         </p:txBody>
       </p:sp>
@@ -280,10 +295,9 @@
           </a:lstStyle>
           <a:p>
             <a:r>
-              <a:rPr lang="en-US" smtClean="0"/>
+              <a:rPr lang="en-US"/>
               <a:t>Click to edit Master subtitle style</a:t>
             </a:r>
-            <a:endParaRPr lang="en-US"/>
           </a:p>
         </p:txBody>
       </p:sp>
@@ -304,7 +318,7 @@
           <a:p>
             <a:fld id="{5BCAD085-E8A6-8845-BD4E-CB4CCA059FC4}" type="datetimeFigureOut">
               <a:rPr lang="en-US" smtClean="0"/>
-              <a:t>1/27/13</a:t>
+              <a:t>10/13/26</a:t>
             </a:fld>
             <a:endParaRPr lang="en-US"/>
           </a:p>
@@ -398,10 +412,9 @@
           <a:lstStyle/>
           <a:p>
             <a:r>
-              <a:rPr lang="en-US" smtClean="0"/>
+              <a:rPr lang="en-US"/>
               <a:t>Click to edit Master title style</a:t>
             </a:r>
-            <a:endParaRPr lang="en-US"/>
           </a:p>
         </p:txBody>
       </p:sp>
@@ -422,38 +435,37 @@
           <a:p>
             <a:pPr lvl="0"/>
             <a:r>
-              <a:rPr lang="en-US" smtClean="0"/>
+              <a:rPr lang="en-US"/>
               <a:t>Click to edit Master text styles</a:t>
             </a:r>
           </a:p>
           <a:p>
             <a:pPr lvl="1"/>
             <a:r>
-              <a:rPr lang="en-US" smtClean="0"/>
+              <a:rPr lang="en-US"/>
               <a:t>Second level</a:t>
             </a:r>
           </a:p>
           <a:p>
             <a:pPr lvl="2"/>
             <a:r>
-              <a:rPr lang="en-US" smtClean="0"/>
+              <a:rPr lang="en-US"/>
               <a:t>Third level</a:t>
             </a:r>
           </a:p>
           <a:p>
             <a:pPr lvl="3"/>
             <a:r>
-              <a:rPr lang="en-US" smtClean="0"/>
+              <a:rPr lang="en-US"/>
               <a:t>Fourth level</a:t>
             </a:r>
           </a:p>
           <a:p>
             <a:pPr lvl="4"/>
             <a:r>
-              <a:rPr lang="en-US" smtClean="0"/>
+              <a:rPr lang="en-US"/>
               <a:t>Fifth level</a:t>
             </a:r>
-            <a:endParaRPr lang="en-US"/>
           </a:p>
         </p:txBody>
       </p:sp>
@@ -474,7 +486,7 @@
           <a:p>
             <a:fld id="{5BCAD085-E8A6-8845-BD4E-CB4CCA059FC4}" type="datetimeFigureOut">
               <a:rPr lang="en-US" smtClean="0"/>
-              <a:t>1/27/13</a:t>
+              <a:t>10/13/26</a:t>
             </a:fld>
             <a:endParaRPr lang="en-US"/>
           </a:p>
@@ -573,10 +585,9 @@
           <a:lstStyle/>
           <a:p>
             <a:r>
-              <a:rPr lang="en-US" smtClean="0"/>
+              <a:rPr lang="en-US"/>
               <a:t>Click to edit Master title style</a:t>
             </a:r>
-            <a:endParaRPr lang="en-US"/>
           </a:p>
         </p:txBody>
       </p:sp>
@@ -602,38 +613,37 @@
           <a:p>
             <a:pPr lvl="0"/>
             <a:r>
-              <a:rPr lang="en-US" smtClean="0"/>
+              <a:rPr lang="en-US"/>
               <a:t>Click to edit Master text styles</a:t>
             </a:r>
           </a:p>
           <a:p>
             <a:pPr lvl="1"/>
             <a:r>
-              <a:rPr lang="en-US" smtClean="0"/>
+              <a:rPr lang="en-US"/>
               <a:t>Second level</a:t>
             </a:r>
           </a:p>
           <a:p>
             <a:pPr lvl="2"/>
             <a:r>
-              <a:rPr lang="en-US" smtClean="0"/>
+              <a:rPr lang="en-US"/>
               <a:t>Third level</a:t>
             </a:r>
           </a:p>
           <a:p>
             <a:pPr lvl="3"/>
             <a:r>
-              <a:rPr lang="en-US" smtClean="0"/>
+              <a:rPr lang="en-US"/>
               <a:t>Fourth level</a:t>
             </a:r>
           </a:p>
           <a:p>
             <a:pPr lvl="4"/>
             <a:r>
-              <a:rPr lang="en-US" smtClean="0"/>
+              <a:rPr lang="en-US"/>
               <a:t>Fifth level</a:t>
             </a:r>
-            <a:endParaRPr lang="en-US"/>
           </a:p>
         </p:txBody>
       </p:sp>
@@ -654,7 +664,7 @@
           <a:p>
             <a:fld id="{5BCAD085-E8A6-8845-BD4E-CB4CCA059FC4}" type="datetimeFigureOut">
               <a:rPr lang="en-US" smtClean="0"/>
-              <a:t>1/27/13</a:t>
+              <a:t>10/13/26</a:t>
             </a:fld>
             <a:endParaRPr lang="en-US"/>
           </a:p>
@@ -748,10 +758,9 @@
           <a:lstStyle/>
           <a:p>
             <a:r>
-              <a:rPr lang="en-US" smtClean="0"/>
+              <a:rPr lang="en-US"/>
               <a:t>Click to edit Master title style</a:t>
             </a:r>
-            <a:endParaRPr lang="en-US"/>
           </a:p>
         </p:txBody>
       </p:sp>
@@ -772,38 +781,37 @@
           <a:p>
             <a:pPr lvl="0"/>
             <a:r>
-              <a:rPr lang="en-US" smtClean="0"/>
+              <a:rPr lang="en-US"/>
               <a:t>Click to edit Master text styles</a:t>
             </a:r>
           </a:p>
           <a:p>
             <a:pPr lvl="1"/>
             <a:r>
-              <a:rPr lang="en-US" smtClean="0"/>
+              <a:rPr lang="en-US"/>
               <a:t>Second level</a:t>
             </a:r>
           </a:p>
           <a:p>
             <a:pPr lvl="2"/>
             <a:r>
-              <a:rPr lang="en-US" smtClean="0"/>
+              <a:rPr lang="en-US"/>
               <a:t>Third level</a:t>
             </a:r>
           </a:p>
           <a:p>
             <a:pPr lvl="3"/>
             <a:r>
-              <a:rPr lang="en-US" smtClean="0"/>
+              <a:rPr lang="en-US"/>
               <a:t>Fourth level</a:t>
             </a:r>
           </a:p>
           <a:p>
             <a:pPr lvl="4"/>
             <a:r>
-              <a:rPr lang="en-US" smtClean="0"/>
+              <a:rPr lang="en-US"/>
               <a:t>Fifth level</a:t>
             </a:r>
-            <a:endParaRPr lang="en-US"/>
           </a:p>
         </p:txBody>
       </p:sp>
@@ -824,7 +832,7 @@
           <a:p>
             <a:fld id="{5BCAD085-E8A6-8845-BD4E-CB4CCA059FC4}" type="datetimeFigureOut">
               <a:rPr lang="en-US" smtClean="0"/>
-              <a:t>1/27/13</a:t>
+              <a:t>10/13/26</a:t>
             </a:fld>
             <a:endParaRPr lang="en-US"/>
           </a:p>
@@ -927,10 +935,9 @@
           </a:lstStyle>
           <a:p>
             <a:r>
-              <a:rPr lang="en-US" smtClean="0"/>
+              <a:rPr lang="en-US"/>
               <a:t>Click to edit Master title style</a:t>
             </a:r>
-            <a:endParaRPr lang="en-US"/>
           </a:p>
         </p:txBody>
       </p:sp>
@@ -1047,7 +1054,7 @@
           <a:p>
             <a:pPr lvl="0"/>
             <a:r>
-              <a:rPr lang="en-US" smtClean="0"/>
+              <a:rPr lang="en-US"/>
               <a:t>Click to edit Master text styles</a:t>
             </a:r>
           </a:p>
@@ -1070,7 +1077,7 @@
           <a:p>
             <a:fld id="{5BCAD085-E8A6-8845-BD4E-CB4CCA059FC4}" type="datetimeFigureOut">
               <a:rPr lang="en-US" smtClean="0"/>
-              <a:t>1/27/13</a:t>
+              <a:t>10/13/26</a:t>
             </a:fld>
             <a:endParaRPr lang="en-US"/>
           </a:p>
@@ -1164,10 +1171,9 @@
           <a:lstStyle/>
           <a:p>
             <a:r>
-              <a:rPr lang="en-US" smtClean="0"/>
+              <a:rPr lang="en-US"/>
               <a:t>Click to edit Master title style</a:t>
             </a:r>
-            <a:endParaRPr lang="en-US"/>
           </a:p>
         </p:txBody>
       </p:sp>
@@ -1221,38 +1227,37 @@
           <a:p>
             <a:pPr lvl="0"/>
             <a:r>
-              <a:rPr lang="en-US" smtClean="0"/>
+              <a:rPr lang="en-US"/>
               <a:t>Click to edit Master text styles</a:t>
             </a:r>
           </a:p>
           <a:p>
             <a:pPr lvl="1"/>
             <a:r>
-              <a:rPr lang="en-US" smtClean="0"/>
+              <a:rPr lang="en-US"/>
               <a:t>Second level</a:t>
             </a:r>
           </a:p>
           <a:p>
             <a:pPr lvl="2"/>
             <a:r>
-              <a:rPr lang="en-US" smtClean="0"/>
+              <a:rPr lang="en-US"/>
               <a:t>Third level</a:t>
             </a:r>
           </a:p>
           <a:p>
             <a:pPr lvl="3"/>
             <a:r>
-              <a:rPr lang="en-US" smtClean="0"/>
+              <a:rPr lang="en-US"/>
               <a:t>Fourth level</a:t>
             </a:r>
           </a:p>
           <a:p>
             <a:pPr lvl="4"/>
             <a:r>
-              <a:rPr lang="en-US" smtClean="0"/>
+              <a:rPr lang="en-US"/>
               <a:t>Fifth level</a:t>
             </a:r>
-            <a:endParaRPr lang="en-US"/>
           </a:p>
         </p:txBody>
       </p:sp>
@@ -1306,38 +1311,37 @@
           <a:p>
             <a:pPr lvl="0"/>
             <a:r>
-              <a:rPr lang="en-US" smtClean="0"/>
+              <a:rPr lang="en-US"/>
               <a:t>Click to edit Master text styles</a:t>
             </a:r>
           </a:p>
           <a:p>
             <a:pPr lvl="1"/>
             <a:r>
-              <a:rPr lang="en-US" smtClean="0"/>
+              <a:rPr lang="en-US"/>
               <a:t>Second level</a:t>
             </a:r>
           </a:p>
           <a:p>
             <a:pPr lvl="2"/>
             <a:r>
-              <a:rPr lang="en-US" smtClean="0"/>
+              <a:rPr lang="en-US"/>
               <a:t>Third level</a:t>
             </a:r>
           </a:p>
           <a:p>
             <a:pPr lvl="3"/>
             <a:r>
-              <a:rPr lang="en-US" smtClean="0"/>
+              <a:rPr lang="en-US"/>
               <a:t>Fourth level</a:t>
             </a:r>
           </a:p>
           <a:p>
             <a:pPr lvl="4"/>
             <a:r>
-              <a:rPr lang="en-US" smtClean="0"/>
+              <a:rPr lang="en-US"/>
               <a:t>Fifth level</a:t>
             </a:r>
-            <a:endParaRPr lang="en-US"/>
           </a:p>
         </p:txBody>
       </p:sp>
@@ -1358,7 +1362,7 @@
           <a:p>
             <a:fld id="{5BCAD085-E8A6-8845-BD4E-CB4CCA059FC4}" type="datetimeFigureOut">
               <a:rPr lang="en-US" smtClean="0"/>
-              <a:t>1/27/13</a:t>
+              <a:t>10/13/26</a:t>
             </a:fld>
             <a:endParaRPr lang="en-US"/>
           </a:p>
@@ -1456,10 +1460,9 @@
           </a:lstStyle>
           <a:p>
             <a:r>
-              <a:rPr lang="en-US" smtClean="0"/>
+              <a:rPr lang="en-US"/>
               <a:t>Click to edit Master title style</a:t>
             </a:r>
-            <a:endParaRPr lang="en-US"/>
           </a:p>
         </p:txBody>
       </p:sp>
@@ -1522,7 +1525,7 @@
           <a:p>
             <a:pPr lvl="0"/>
             <a:r>
-              <a:rPr lang="en-US" smtClean="0"/>
+              <a:rPr lang="en-US"/>
               <a:t>Click to edit Master text styles</a:t>
             </a:r>
           </a:p>
@@ -1578,38 +1581,37 @@
           <a:p>
             <a:pPr lvl="0"/>
             <a:r>
-              <a:rPr lang="en-US" smtClean="0"/>
+              <a:rPr lang="en-US"/>
               <a:t>Click to edit Master text styles</a:t>
             </a:r>
           </a:p>
           <a:p>
             <a:pPr lvl="1"/>
             <a:r>
-              <a:rPr lang="en-US" smtClean="0"/>
+              <a:rPr lang="en-US"/>
               <a:t>Second level</a:t>
             </a:r>
           </a:p>
           <a:p>
             <a:pPr lvl="2"/>
             <a:r>
-              <a:rPr lang="en-US" smtClean="0"/>
+              <a:rPr lang="en-US"/>
               <a:t>Third level</a:t>
             </a:r>
           </a:p>
           <a:p>
             <a:pPr lvl="3"/>
             <a:r>
-              <a:rPr lang="en-US" smtClean="0"/>
+              <a:rPr lang="en-US"/>
               <a:t>Fourth level</a:t>
             </a:r>
           </a:p>
           <a:p>
             <a:pPr lvl="4"/>
             <a:r>
-              <a:rPr lang="en-US" smtClean="0"/>
+              <a:rPr lang="en-US"/>
               <a:t>Fifth level</a:t>
             </a:r>
-            <a:endParaRPr lang="en-US"/>
           </a:p>
         </p:txBody>
       </p:sp>
@@ -1672,7 +1674,7 @@
           <a:p>
             <a:pPr lvl="0"/>
             <a:r>
-              <a:rPr lang="en-US" smtClean="0"/>
+              <a:rPr lang="en-US"/>
               <a:t>Click to edit Master text styles</a:t>
             </a:r>
           </a:p>
@@ -1728,38 +1730,37 @@
           <a:p>
             <a:pPr lvl="0"/>
             <a:r>
-              <a:rPr lang="en-US" smtClean="0"/>
+              <a:rPr lang="en-US"/>
               <a:t>Click to edit Master text styles</a:t>
             </a:r>
           </a:p>
           <a:p>
             <a:pPr lvl="1"/>
             <a:r>
-              <a:rPr lang="en-US" smtClean="0"/>
+              <a:rPr lang="en-US"/>
               <a:t>Second level</a:t>
             </a:r>
           </a:p>
           <a:p>
             <a:pPr lvl="2"/>
             <a:r>
-              <a:rPr lang="en-US" smtClean="0"/>
+              <a:rPr lang="en-US"/>
               <a:t>Third level</a:t>
             </a:r>
           </a:p>
           <a:p>
             <a:pPr lvl="3"/>
             <a:r>
-              <a:rPr lang="en-US" smtClean="0"/>
+              <a:rPr lang="en-US"/>
               <a:t>Fourth level</a:t>
             </a:r>
           </a:p>
           <a:p>
             <a:pPr lvl="4"/>
             <a:r>
-              <a:rPr lang="en-US" smtClean="0"/>
+              <a:rPr lang="en-US"/>
               <a:t>Fifth level</a:t>
             </a:r>
-            <a:endParaRPr lang="en-US"/>
           </a:p>
         </p:txBody>
       </p:sp>
@@ -1780,7 +1781,7 @@
           <a:p>
             <a:fld id="{5BCAD085-E8A6-8845-BD4E-CB4CCA059FC4}" type="datetimeFigureOut">
               <a:rPr lang="en-US" smtClean="0"/>
-              <a:t>1/27/13</a:t>
+              <a:t>10/13/26</a:t>
             </a:fld>
             <a:endParaRPr lang="en-US"/>
           </a:p>
@@ -1874,10 +1875,9 @@
           <a:lstStyle/>
           <a:p>
             <a:r>
-              <a:rPr lang="en-US" smtClean="0"/>
+              <a:rPr lang="en-US"/>
               <a:t>Click to edit Master title style</a:t>
             </a:r>
-            <a:endParaRPr lang="en-US"/>
           </a:p>
         </p:txBody>
       </p:sp>
@@ -1898,7 +1898,7 @@
           <a:p>
             <a:fld id="{5BCAD085-E8A6-8845-BD4E-CB4CCA059FC4}" type="datetimeFigureOut">
               <a:rPr lang="en-US" smtClean="0"/>
-              <a:t>1/27/13</a:t>
+              <a:t>10/13/26</a:t>
             </a:fld>
             <a:endParaRPr lang="en-US"/>
           </a:p>
@@ -1993,7 +1993,7 @@
           <a:p>
             <a:fld id="{5BCAD085-E8A6-8845-BD4E-CB4CCA059FC4}" type="datetimeFigureOut">
               <a:rPr lang="en-US" smtClean="0"/>
-              <a:t>1/27/13</a:t>
+              <a:t>10/13/26</a:t>
             </a:fld>
             <a:endParaRPr lang="en-US"/>
           </a:p>
@@ -2096,10 +2096,9 @@
           </a:lstStyle>
           <a:p>
             <a:r>
-              <a:rPr lang="en-US" smtClean="0"/>
+              <a:rPr lang="en-US"/>
               <a:t>Click to edit Master title style</a:t>
             </a:r>
-            <a:endParaRPr lang="en-US"/>
           </a:p>
         </p:txBody>
       </p:sp>
@@ -2153,38 +2152,37 @@
           <a:p>
             <a:pPr lvl="0"/>
             <a:r>
-              <a:rPr lang="en-US" smtClean="0"/>
+              <a:rPr lang="en-US"/>
               <a:t>Click to edit Master text styles</a:t>
             </a:r>
           </a:p>
           <a:p>
             <a:pPr lvl="1"/>
             <a:r>
-              <a:rPr lang="en-US" smtClean="0"/>
+              <a:rPr lang="en-US"/>
               <a:t>Second level</a:t>
             </a:r>
           </a:p>
           <a:p>
             <a:pPr lvl="2"/>
             <a:r>
-              <a:rPr lang="en-US" smtClean="0"/>
+              <a:rPr lang="en-US"/>
               <a:t>Third level</a:t>
             </a:r>
           </a:p>
           <a:p>
             <a:pPr lvl="3"/>
             <a:r>
-              <a:rPr lang="en-US" smtClean="0"/>
+              <a:rPr lang="en-US"/>
               <a:t>Fourth level</a:t>
             </a:r>
           </a:p>
           <a:p>
             <a:pPr lvl="4"/>
             <a:r>
-              <a:rPr lang="en-US" smtClean="0"/>
+              <a:rPr lang="en-US"/>
               <a:t>Fifth level</a:t>
             </a:r>
-            <a:endParaRPr lang="en-US"/>
           </a:p>
         </p:txBody>
       </p:sp>
@@ -2247,7 +2245,7 @@
           <a:p>
             <a:pPr lvl="0"/>
             <a:r>
-              <a:rPr lang="en-US" smtClean="0"/>
+              <a:rPr lang="en-US"/>
               <a:t>Click to edit Master text styles</a:t>
             </a:r>
           </a:p>
@@ -2270,7 +2268,7 @@
           <a:p>
             <a:fld id="{5BCAD085-E8A6-8845-BD4E-CB4CCA059FC4}" type="datetimeFigureOut">
               <a:rPr lang="en-US" smtClean="0"/>
-              <a:t>1/27/13</a:t>
+              <a:t>10/13/26</a:t>
             </a:fld>
             <a:endParaRPr lang="en-US"/>
           </a:p>
@@ -2373,10 +2371,9 @@
           </a:lstStyle>
           <a:p>
             <a:r>
-              <a:rPr lang="en-US" smtClean="0"/>
+              <a:rPr lang="en-US"/>
               <a:t>Click to edit Master title style</a:t>
             </a:r>
-            <a:endParaRPr lang="en-US"/>
           </a:p>
         </p:txBody>
       </p:sp>
@@ -2500,7 +2497,7 @@
           <a:p>
             <a:pPr lvl="0"/>
             <a:r>
-              <a:rPr lang="en-US" smtClean="0"/>
+              <a:rPr lang="en-US"/>
               <a:t>Click to edit Master text styles</a:t>
             </a:r>
           </a:p>
@@ -2523,7 +2520,7 @@
           <a:p>
             <a:fld id="{5BCAD085-E8A6-8845-BD4E-CB4CCA059FC4}" type="datetimeFigureOut">
               <a:rPr lang="en-US" smtClean="0"/>
-              <a:t>1/27/13</a:t>
+              <a:t>10/13/26</a:t>
             </a:fld>
             <a:endParaRPr lang="en-US"/>
           </a:p>
@@ -2632,10 +2629,9 @@
           <a:lstStyle/>
           <a:p>
             <a:r>
-              <a:rPr lang="en-US" smtClean="0"/>
+              <a:rPr lang="en-US"/>
               <a:t>Click to edit Master title style</a:t>
             </a:r>
-            <a:endParaRPr lang="en-US"/>
           </a:p>
         </p:txBody>
       </p:sp>
@@ -2666,38 +2662,37 @@
           <a:p>
             <a:pPr lvl="0"/>
             <a:r>
-              <a:rPr lang="en-US" smtClean="0"/>
+              <a:rPr lang="en-US"/>
               <a:t>Click to edit Master text styles</a:t>
             </a:r>
           </a:p>
           <a:p>
             <a:pPr lvl="1"/>
             <a:r>
-              <a:rPr lang="en-US" smtClean="0"/>
+              <a:rPr lang="en-US"/>
               <a:t>Second level</a:t>
             </a:r>
           </a:p>
           <a:p>
             <a:pPr lvl="2"/>
             <a:r>
-              <a:rPr lang="en-US" smtClean="0"/>
+              <a:rPr lang="en-US"/>
               <a:t>Third level</a:t>
             </a:r>
           </a:p>
           <a:p>
             <a:pPr lvl="3"/>
             <a:r>
-              <a:rPr lang="en-US" smtClean="0"/>
+              <a:rPr lang="en-US"/>
               <a:t>Fourth level</a:t>
             </a:r>
           </a:p>
           <a:p>
             <a:pPr lvl="4"/>
             <a:r>
-              <a:rPr lang="en-US" smtClean="0"/>
+              <a:rPr lang="en-US"/>
               <a:t>Fifth level</a:t>
             </a:r>
-            <a:endParaRPr lang="en-US"/>
           </a:p>
         </p:txBody>
       </p:sp>
@@ -2736,7 +2731,7 @@
           <a:p>
             <a:fld id="{5BCAD085-E8A6-8845-BD4E-CB4CCA059FC4}" type="datetimeFigureOut">
               <a:rPr lang="en-US" smtClean="0"/>
-              <a:t>1/27/13</a:t>
+              <a:t>10/13/26</a:t>
             </a:fld>
             <a:endParaRPr lang="en-US"/>
           </a:p>
@@ -3095,7 +3090,7 @@
 </file>
 
 <file path=ppt/slides/slide1.xml><?xml version="1.0" encoding="utf-8"?>
-<p:sld xmlns:a="http://schemas.openxmlformats.org/drawingml/2006/main" xmlns:p="http://schemas.openxmlformats.org/presentationml/2006/main" xmlns:r="http://schemas.openxmlformats.org/officeDocument/2006/relationships">
+<p:sld xmlns:a="http://schemas.openxmlformats.org/drawingml/2006/main" xmlns:r="http://schemas.openxmlformats.org/officeDocument/2006/relationships" xmlns:p="http://schemas.openxmlformats.org/presentationml/2006/main">
   <p:cSld>
     <p:bg>
       <p:bgPr>
@@ -3111,7 +3106,14 @@
         <p:cNvGrpSpPr/>
         <p:nvPr/>
       </p:nvGrpSpPr>
-      <p:grpSpPr/>
+      <p:grpSpPr>
+        <a:xfrm>
+          <a:off x="0" y="0"/>
+          <a:ext cx="0" cy="0"/>
+          <a:chOff x="0" y="0"/>
+          <a:chExt cx="0" cy="0"/>
+        </a:xfrm>
+      </p:grpSpPr>
       <p:pic>
         <p:nvPicPr>
           <p:cNvPr id="2" name="Picture 1" descr="hero_cover_banner.png"/>
@@ -3208,7 +3210,7 @@
           </a:fontRef>
         </p:style>
         <p:txBody>
-          <a:bodyPr rtlCol="0" anchor="ctr" wrap="none" lIns="128016" rIns="128016" tIns="36576" bIns="36576"/>
+          <a:bodyPr wrap="none" lIns="128016" tIns="36576" rIns="128016" bIns="36576" rtlCol="0" anchor="ctr"/>
           <a:lstStyle/>
           <a:p>
             <a:pPr algn="ctr">
@@ -3306,7 +3308,7 @@
 </file>
 
 <file path=ppt/slides/slide10.xml><?xml version="1.0" encoding="utf-8"?>
-<p:sld xmlns:a="http://schemas.openxmlformats.org/drawingml/2006/main" xmlns:p="http://schemas.openxmlformats.org/presentationml/2006/main" xmlns:r="http://schemas.openxmlformats.org/officeDocument/2006/relationships">
+<p:sld xmlns:a="http://schemas.openxmlformats.org/drawingml/2006/main" xmlns:r="http://schemas.openxmlformats.org/officeDocument/2006/relationships" xmlns:p="http://schemas.openxmlformats.org/presentationml/2006/main">
   <p:cSld>
     <p:bg>
       <p:bgPr>
@@ -3322,7 +3324,14 @@
         <p:cNvGrpSpPr/>
         <p:nvPr/>
       </p:nvGrpSpPr>
-      <p:grpSpPr/>
+      <p:grpSpPr>
+        <a:xfrm>
+          <a:off x="0" y="0"/>
+          <a:ext cx="0" cy="0"/>
+          <a:chOff x="0" y="0"/>
+          <a:chExt cx="0" cy="0"/>
+        </a:xfrm>
+      </p:grpSpPr>
       <p:sp>
         <p:nvSpPr>
           <p:cNvPr id="2" name="Rounded Rectangle 1"/>
@@ -3359,7 +3368,7 @@
           </a:fontRef>
         </p:style>
         <p:txBody>
-          <a:bodyPr rtlCol="0" anchor="ctr" wrap="none" lIns="128016" rIns="128016" tIns="36576" bIns="36576"/>
+          <a:bodyPr wrap="none" lIns="128016" tIns="36576" rIns="128016" bIns="36576" rtlCol="0" anchor="ctr"/>
           <a:lstStyle/>
           <a:p>
             <a:pPr algn="ctr">
@@ -3420,8 +3429,8 @@
         </p:nvSpPr>
         <p:spPr>
           <a:xfrm>
-            <a:off x="731520" y="1737360"/>
-            <a:ext cx="3328416" cy="4572000"/>
+            <a:off x="731519" y="1392865"/>
+            <a:ext cx="3340609" cy="4920748"/>
           </a:xfrm>
           <a:prstGeom prst="roundRect">
             <a:avLst/>
@@ -3450,7 +3459,7 @@
           </a:fontRef>
         </p:style>
         <p:txBody>
-          <a:bodyPr rtlCol="0" anchor="ctr" wrap="square" lIns="182880" rIns="182880" tIns="228600"/>
+          <a:bodyPr wrap="square" lIns="182880" tIns="228600" rIns="182880" rtlCol="0" anchor="ctr"/>
           <a:lstStyle/>
           <a:p>
             <a:pPr algn="ctr">
@@ -3462,6 +3471,7 @@
               </a:defRPr>
             </a:pPr>
             <a:r>
+              <a:rPr dirty="0"/>
               <a:t>DIJKSTRA'S SSSP</a:t>
             </a:r>
           </a:p>
@@ -3475,46 +3485,235 @@
               </a:defRPr>
             </a:pPr>
             <a:r>
-              <a:t>MIN-HEAP GREEDY • O((V+E)logV)</a:t>
-            </a:r>
-          </a:p>
-          <a:p>
-            <a:br/>
-            <a:pPr>
-              <a:defRPr sz="1200">
-                <a:solidFill>
-                  <a:srgbClr val="241C1C"/>
-                </a:solidFill>
-                <a:latin typeface="Inter"/>
-              </a:defRPr>
-            </a:pPr>
-            <a:r>
+              <a:rPr dirty="0"/>
+              <a:t>MIN-HEAP GREEDY • O((V+E)</a:t>
+            </a:r>
+            <a:r>
+              <a:rPr dirty="0" err="1"/>
+              <a:t>logV</a:t>
+            </a:r>
+            <a:r>
+              <a:rPr dirty="0"/>
+              <a:t>)</a:t>
+            </a:r>
+          </a:p>
+          <a:p>
+            <a:br>
+              <a:rPr sz="1600" dirty="0">
+                <a:solidFill>
+                  <a:schemeClr val="tx1"/>
+                </a:solidFill>
+              </a:rPr>
+            </a:br>
+            <a:r>
+              <a:rPr sz="1600" dirty="0">
+                <a:solidFill>
+                  <a:schemeClr val="tx1"/>
+                </a:solidFill>
+              </a:rPr>
               <a:t>Algorithmic Mechanics:</a:t>
             </a:r>
-            <a:br/>
-            <a:r>
-              <a:t>• Initialize dist[start] = 0, dist[v] = ∞</a:t>
-            </a:r>
-            <a:br/>
-            <a:r>
+            <a:br>
+              <a:rPr sz="1600" dirty="0">
+                <a:solidFill>
+                  <a:schemeClr val="tx1"/>
+                </a:solidFill>
+              </a:rPr>
+            </a:br>
+            <a:r>
+              <a:rPr sz="1600" dirty="0">
+                <a:solidFill>
+                  <a:schemeClr val="tx1"/>
+                </a:solidFill>
+              </a:rPr>
+              <a:t>• Initialize </a:t>
+            </a:r>
+            <a:r>
+              <a:rPr sz="1600" dirty="0" err="1">
+                <a:solidFill>
+                  <a:schemeClr val="tx1"/>
+                </a:solidFill>
+              </a:rPr>
+              <a:t>dist</a:t>
+            </a:r>
+            <a:r>
+              <a:rPr sz="1600" dirty="0">
+                <a:solidFill>
+                  <a:schemeClr val="tx1"/>
+                </a:solidFill>
+              </a:rPr>
+              <a:t>[start] = 0, </a:t>
+            </a:r>
+            <a:r>
+              <a:rPr sz="1600" dirty="0" err="1">
+                <a:solidFill>
+                  <a:schemeClr val="tx1"/>
+                </a:solidFill>
+              </a:rPr>
+              <a:t>dist</a:t>
+            </a:r>
+            <a:r>
+              <a:rPr sz="1600" dirty="0">
+                <a:solidFill>
+                  <a:schemeClr val="tx1"/>
+                </a:solidFill>
+              </a:rPr>
+              <a:t>[v] = ∞</a:t>
+            </a:r>
+            <a:br>
+              <a:rPr sz="1600" dirty="0">
+                <a:solidFill>
+                  <a:schemeClr val="tx1"/>
+                </a:solidFill>
+              </a:rPr>
+            </a:br>
+            <a:r>
+              <a:rPr sz="1600" dirty="0">
+                <a:solidFill>
+                  <a:schemeClr val="tx1"/>
+                </a:solidFill>
+              </a:rPr>
               <a:t>• Push (0, start) to custom Min-Heap Priority Queue.</a:t>
             </a:r>
-            <a:br/>
-            <a:r>
+            <a:br>
+              <a:rPr sz="1600" dirty="0">
+                <a:solidFill>
+                  <a:schemeClr val="tx1"/>
+                </a:solidFill>
+              </a:rPr>
+            </a:br>
+            <a:r>
+              <a:rPr sz="1600" dirty="0">
+                <a:solidFill>
+                  <a:schemeClr val="tx1"/>
+                </a:solidFill>
+              </a:rPr>
               <a:t>• Invariant: Extract vertex u with minimum tentative distance. It is permanently finalized.</a:t>
             </a:r>
-            <a:br/>
-            <a:r>
+            <a:br>
+              <a:rPr sz="1600" dirty="0">
+                <a:solidFill>
+                  <a:schemeClr val="tx1"/>
+                </a:solidFill>
+              </a:rPr>
+            </a:br>
+            <a:r>
+              <a:rPr sz="1600" dirty="0">
+                <a:solidFill>
+                  <a:schemeClr val="tx1"/>
+                </a:solidFill>
+              </a:rPr>
               <a:t>• Edge Relaxation:</a:t>
             </a:r>
-            <a:br/>
-            <a:r>
-              <a:t>  dist[v] = min(dist[v], dist[u] + w(u,v))</a:t>
-            </a:r>
-            <a:br/>
-            <a:br/>
-            <a:r>
-              <a:t>Limitation: Requires w(u,v) &gt;= 0. Cannot handle negative toll credits.</a:t>
+            <a:br>
+              <a:rPr sz="1600" dirty="0">
+                <a:solidFill>
+                  <a:schemeClr val="tx1"/>
+                </a:solidFill>
+              </a:rPr>
+            </a:br>
+            <a:r>
+              <a:rPr sz="1600" dirty="0">
+                <a:solidFill>
+                  <a:schemeClr val="tx1"/>
+                </a:solidFill>
+              </a:rPr>
+              <a:t>  </a:t>
+            </a:r>
+            <a:r>
+              <a:rPr sz="1600" dirty="0" err="1">
+                <a:solidFill>
+                  <a:schemeClr val="tx1"/>
+                </a:solidFill>
+              </a:rPr>
+              <a:t>dist</a:t>
+            </a:r>
+            <a:r>
+              <a:rPr sz="1600" dirty="0">
+                <a:solidFill>
+                  <a:schemeClr val="tx1"/>
+                </a:solidFill>
+              </a:rPr>
+              <a:t>[v] = min(</a:t>
+            </a:r>
+            <a:r>
+              <a:rPr sz="1600" dirty="0" err="1">
+                <a:solidFill>
+                  <a:schemeClr val="tx1"/>
+                </a:solidFill>
+              </a:rPr>
+              <a:t>dist</a:t>
+            </a:r>
+            <a:r>
+              <a:rPr sz="1600" dirty="0">
+                <a:solidFill>
+                  <a:schemeClr val="tx1"/>
+                </a:solidFill>
+              </a:rPr>
+              <a:t>[v], </a:t>
+            </a:r>
+            <a:r>
+              <a:rPr sz="1600" dirty="0" err="1">
+                <a:solidFill>
+                  <a:schemeClr val="tx1"/>
+                </a:solidFill>
+              </a:rPr>
+              <a:t>dist</a:t>
+            </a:r>
+            <a:r>
+              <a:rPr sz="1600" dirty="0">
+                <a:solidFill>
+                  <a:schemeClr val="tx1"/>
+                </a:solidFill>
+              </a:rPr>
+              <a:t>[u] + w(</a:t>
+            </a:r>
+            <a:r>
+              <a:rPr sz="1600" dirty="0" err="1">
+                <a:solidFill>
+                  <a:schemeClr val="tx1"/>
+                </a:solidFill>
+              </a:rPr>
+              <a:t>u,v</a:t>
+            </a:r>
+            <a:r>
+              <a:rPr sz="1600" dirty="0">
+                <a:solidFill>
+                  <a:schemeClr val="tx1"/>
+                </a:solidFill>
+              </a:rPr>
+              <a:t>))</a:t>
+            </a:r>
+            <a:br>
+              <a:rPr sz="1600" dirty="0">
+                <a:solidFill>
+                  <a:schemeClr val="tx1"/>
+                </a:solidFill>
+              </a:rPr>
+            </a:br>
+            <a:r>
+              <a:rPr sz="1600" dirty="0">
+                <a:solidFill>
+                  <a:schemeClr val="tx1"/>
+                </a:solidFill>
+              </a:rPr>
+              <a:t>Limitation: Requires w(</a:t>
+            </a:r>
+            <a:r>
+              <a:rPr sz="1600" dirty="0" err="1">
+                <a:solidFill>
+                  <a:schemeClr val="tx1"/>
+                </a:solidFill>
+              </a:rPr>
+              <a:t>u,v</a:t>
+            </a:r>
+            <a:r>
+              <a:rPr sz="1600" dirty="0">
+                <a:solidFill>
+                  <a:schemeClr val="tx1"/>
+                </a:solidFill>
+              </a:rPr>
+              <a:t>) &gt;= 0. Cannot handle negative toll credits.</a:t>
             </a:r>
           </a:p>
         </p:txBody>
@@ -3527,8 +3726,8 @@
         </p:nvSpPr>
         <p:spPr>
           <a:xfrm>
-            <a:off x="4425696" y="1737360"/>
-            <a:ext cx="3328416" cy="4572000"/>
+            <a:off x="4425696" y="1392865"/>
+            <a:ext cx="3310128" cy="4916495"/>
           </a:xfrm>
           <a:prstGeom prst="roundRect">
             <a:avLst/>
@@ -3557,7 +3756,7 @@
           </a:fontRef>
         </p:style>
         <p:txBody>
-          <a:bodyPr rtlCol="0" anchor="ctr" wrap="square" lIns="182880" rIns="182880" tIns="228600"/>
+          <a:bodyPr wrap="square" lIns="182880" tIns="228600" rIns="182880" rtlCol="0" anchor="ctr"/>
           <a:lstStyle/>
           <a:p>
             <a:pPr algn="ctr">
@@ -3569,6 +3768,7 @@
               </a:defRPr>
             </a:pPr>
             <a:r>
+              <a:rPr dirty="0"/>
               <a:t>BELLMAN-FORD ALGORITHM</a:t>
             </a:r>
           </a:p>
@@ -3582,42 +3782,145 @@
               </a:defRPr>
             </a:pPr>
             <a:r>
+              <a:rPr dirty="0"/>
               <a:t>DP EDGE RELAXATION • O(V · E)</a:t>
             </a:r>
           </a:p>
           <a:p>
-            <a:br/>
-            <a:pPr>
-              <a:defRPr sz="1200">
-                <a:solidFill>
-                  <a:srgbClr val="241C1C"/>
-                </a:solidFill>
-                <a:latin typeface="Inter"/>
-              </a:defRPr>
-            </a:pPr>
-            <a:r>
+            <a:br>
+              <a:rPr sz="1600" dirty="0">
+                <a:solidFill>
+                  <a:schemeClr val="tx1"/>
+                </a:solidFill>
+              </a:rPr>
+            </a:br>
+            <a:r>
+              <a:rPr sz="1600" dirty="0">
+                <a:solidFill>
+                  <a:schemeClr val="tx1"/>
+                </a:solidFill>
+              </a:rPr>
               <a:t>Algorithmic Mechanics:</a:t>
             </a:r>
-            <a:br/>
-            <a:r>
+            <a:br>
+              <a:rPr sz="1600" dirty="0">
+                <a:solidFill>
+                  <a:schemeClr val="tx1"/>
+                </a:solidFill>
+              </a:rPr>
+            </a:br>
+            <a:r>
+              <a:rPr sz="1600" dirty="0">
+                <a:solidFill>
+                  <a:schemeClr val="tx1"/>
+                </a:solidFill>
+              </a:rPr>
               <a:t>• Relaxes all |E| directed edges for |V| - 1 iterations:</a:t>
             </a:r>
-            <a:br/>
-            <a:r>
-              <a:t>  d^(k)[v] = min(d^(k-1)[v], d^(k-1)[u] + w(u,v))</a:t>
-            </a:r>
-            <a:br/>
-            <a:br/>
-            <a:r>
+            <a:br>
+              <a:rPr sz="1600" dirty="0">
+                <a:solidFill>
+                  <a:schemeClr val="tx1"/>
+                </a:solidFill>
+              </a:rPr>
+            </a:br>
+            <a:r>
+              <a:rPr sz="1600" dirty="0">
+                <a:solidFill>
+                  <a:schemeClr val="tx1"/>
+                </a:solidFill>
+              </a:rPr>
+              <a:t>  d^(k)[v] = min(d^(k-1)[v], d^(k-1)[u] + w(</a:t>
+            </a:r>
+            <a:r>
+              <a:rPr sz="1600" dirty="0" err="1">
+                <a:solidFill>
+                  <a:schemeClr val="tx1"/>
+                </a:solidFill>
+              </a:rPr>
+              <a:t>u,v</a:t>
+            </a:r>
+            <a:r>
+              <a:rPr sz="1600" dirty="0">
+                <a:solidFill>
+                  <a:schemeClr val="tx1"/>
+                </a:solidFill>
+              </a:rPr>
+              <a:t>))</a:t>
+            </a:r>
+            <a:br>
+              <a:rPr sz="1600" dirty="0">
+                <a:solidFill>
+                  <a:schemeClr val="tx1"/>
+                </a:solidFill>
+              </a:rPr>
+            </a:br>
+            <a:br>
+              <a:rPr sz="1600" dirty="0">
+                <a:solidFill>
+                  <a:schemeClr val="tx1"/>
+                </a:solidFill>
+              </a:rPr>
+            </a:br>
+            <a:r>
+              <a:rPr sz="1600" dirty="0">
+                <a:solidFill>
+                  <a:schemeClr val="tx1"/>
+                </a:solidFill>
+              </a:rPr>
               <a:t>• Cycle Detection Invariant:</a:t>
             </a:r>
-            <a:br/>
-            <a:r>
-              <a:t>  If edge (u,v) relaxes on iteration |V|, a negative-weight cycle exists.</a:t>
-            </a:r>
-            <a:br/>
-            <a:br/>
-            <a:r>
+            <a:br>
+              <a:rPr sz="1600" dirty="0">
+                <a:solidFill>
+                  <a:schemeClr val="tx1"/>
+                </a:solidFill>
+              </a:rPr>
+            </a:br>
+            <a:r>
+              <a:rPr sz="1600" dirty="0">
+                <a:solidFill>
+                  <a:schemeClr val="tx1"/>
+                </a:solidFill>
+              </a:rPr>
+              <a:t>  If edge (</a:t>
+            </a:r>
+            <a:r>
+              <a:rPr sz="1600" dirty="0" err="1">
+                <a:solidFill>
+                  <a:schemeClr val="tx1"/>
+                </a:solidFill>
+              </a:rPr>
+              <a:t>u,v</a:t>
+            </a:r>
+            <a:r>
+              <a:rPr sz="1600" dirty="0">
+                <a:solidFill>
+                  <a:schemeClr val="tx1"/>
+                </a:solidFill>
+              </a:rPr>
+              <a:t>) relaxes on iteration |V|, a negative-weight cycle exists.</a:t>
+            </a:r>
+            <a:br>
+              <a:rPr sz="1600" dirty="0">
+                <a:solidFill>
+                  <a:schemeClr val="tx1"/>
+                </a:solidFill>
+              </a:rPr>
+            </a:br>
+            <a:br>
+              <a:rPr sz="1600" dirty="0">
+                <a:solidFill>
+                  <a:schemeClr val="tx1"/>
+                </a:solidFill>
+              </a:rPr>
+            </a:br>
+            <a:r>
+              <a:rPr sz="1600" dirty="0">
+                <a:solidFill>
+                  <a:schemeClr val="tx1"/>
+                </a:solidFill>
+              </a:rPr>
               <a:t>Benefit: Handles dynamic congestion penalties &amp; toll subsidies without failure.</a:t>
             </a:r>
           </a:p>
@@ -3631,8 +3934,8 @@
         </p:nvSpPr>
         <p:spPr>
           <a:xfrm>
-            <a:off x="8119872" y="1737360"/>
-            <a:ext cx="3328416" cy="4572000"/>
+            <a:off x="8119872" y="1392865"/>
+            <a:ext cx="3310128" cy="4916495"/>
           </a:xfrm>
           <a:prstGeom prst="roundRect">
             <a:avLst/>
@@ -3661,7 +3964,7 @@
           </a:fontRef>
         </p:style>
         <p:txBody>
-          <a:bodyPr rtlCol="0" anchor="ctr" wrap="square" lIns="182880" rIns="182880" tIns="228600"/>
+          <a:bodyPr wrap="square" lIns="182880" tIns="228600" rIns="182880" rtlCol="0" anchor="ctr"/>
           <a:lstStyle/>
           <a:p>
             <a:pPr algn="ctr">
@@ -3673,6 +3976,7 @@
               </a:defRPr>
             </a:pPr>
             <a:r>
+              <a:rPr dirty="0"/>
               <a:t>PRACTICAL LOGISTICS ROLE</a:t>
             </a:r>
           </a:p>
@@ -3686,35 +3990,138 @@
               </a:defRPr>
             </a:pPr>
             <a:r>
+              <a:rPr dirty="0"/>
               <a:t>HYBRID DUAL GRAPH ENGINE</a:t>
             </a:r>
           </a:p>
           <a:p>
-            <a:br/>
-            <a:pPr>
-              <a:defRPr sz="1200">
-                <a:solidFill>
-                  <a:srgbClr val="241C1C"/>
-                </a:solidFill>
-                <a:latin typeface="Inter"/>
-              </a:defRPr>
-            </a:pPr>
-            <a:r>
-              <a:t>Operational Synergies in SmartRoute:</a:t>
-            </a:r>
-            <a:br/>
-            <a:br/>
-            <a:r>
-              <a:t>• Primary Navigation: Dijkstra executes in 4.2 ms across Hyderabad corridors for instant turn-by-turn directions.</a:t>
-            </a:r>
-            <a:br/>
-            <a:br/>
-            <a:r>
-              <a:t>• Congestion Audit: Bellman-Ford runs in background (18.7 ms) to detect traffic deadlock loops and model dynamic subsidies.</a:t>
-            </a:r>
-            <a:br/>
-            <a:br/>
-            <a:r>
+            <a:br>
+              <a:rPr sz="1600" dirty="0">
+                <a:solidFill>
+                  <a:schemeClr val="tx1"/>
+                </a:solidFill>
+              </a:rPr>
+            </a:br>
+            <a:r>
+              <a:rPr sz="1600" dirty="0">
+                <a:solidFill>
+                  <a:schemeClr val="tx1"/>
+                </a:solidFill>
+              </a:rPr>
+              <a:t>Operational Synergies in </a:t>
+            </a:r>
+            <a:r>
+              <a:rPr sz="1600" dirty="0" err="1">
+                <a:solidFill>
+                  <a:schemeClr val="tx1"/>
+                </a:solidFill>
+              </a:rPr>
+              <a:t>SmartRoute</a:t>
+            </a:r>
+            <a:r>
+              <a:rPr sz="1600" dirty="0">
+                <a:solidFill>
+                  <a:schemeClr val="tx1"/>
+                </a:solidFill>
+              </a:rPr>
+              <a:t>:</a:t>
+            </a:r>
+            <a:br>
+              <a:rPr sz="1600" dirty="0">
+                <a:solidFill>
+                  <a:schemeClr val="tx1"/>
+                </a:solidFill>
+              </a:rPr>
+            </a:br>
+            <a:br>
+              <a:rPr sz="1600" dirty="0">
+                <a:solidFill>
+                  <a:schemeClr val="tx1"/>
+                </a:solidFill>
+              </a:rPr>
+            </a:br>
+            <a:r>
+              <a:rPr sz="1600" dirty="0">
+                <a:solidFill>
+                  <a:schemeClr val="tx1"/>
+                </a:solidFill>
+              </a:rPr>
+              <a:t>• Primary Navigation: Dijkstra executes in 4.2 </a:t>
+            </a:r>
+            <a:r>
+              <a:rPr sz="1600" dirty="0" err="1">
+                <a:solidFill>
+                  <a:schemeClr val="tx1"/>
+                </a:solidFill>
+              </a:rPr>
+              <a:t>ms</a:t>
+            </a:r>
+            <a:r>
+              <a:rPr sz="1600" dirty="0">
+                <a:solidFill>
+                  <a:schemeClr val="tx1"/>
+                </a:solidFill>
+              </a:rPr>
+              <a:t> across Hyderabad corridors for instant turn-by-turn directions.</a:t>
+            </a:r>
+            <a:br>
+              <a:rPr sz="1600" dirty="0">
+                <a:solidFill>
+                  <a:schemeClr val="tx1"/>
+                </a:solidFill>
+              </a:rPr>
+            </a:br>
+            <a:br>
+              <a:rPr sz="1600" dirty="0">
+                <a:solidFill>
+                  <a:schemeClr val="tx1"/>
+                </a:solidFill>
+              </a:rPr>
+            </a:br>
+            <a:r>
+              <a:rPr sz="1600" dirty="0">
+                <a:solidFill>
+                  <a:schemeClr val="tx1"/>
+                </a:solidFill>
+              </a:rPr>
+              <a:t>• Congestion Audit: Bellman-Ford runs in background (18.7 </a:t>
+            </a:r>
+            <a:r>
+              <a:rPr sz="1600" dirty="0" err="1">
+                <a:solidFill>
+                  <a:schemeClr val="tx1"/>
+                </a:solidFill>
+              </a:rPr>
+              <a:t>ms</a:t>
+            </a:r>
+            <a:r>
+              <a:rPr sz="1600" dirty="0">
+                <a:solidFill>
+                  <a:schemeClr val="tx1"/>
+                </a:solidFill>
+              </a:rPr>
+              <a:t>) to detect traffic deadlock loops and model dynamic subsidies.</a:t>
+            </a:r>
+            <a:br>
+              <a:rPr sz="1600" dirty="0">
+                <a:solidFill>
+                  <a:schemeClr val="tx1"/>
+                </a:solidFill>
+              </a:rPr>
+            </a:br>
+            <a:br>
+              <a:rPr sz="1600" dirty="0">
+                <a:solidFill>
+                  <a:schemeClr val="tx1"/>
+                </a:solidFill>
+              </a:rPr>
+            </a:br>
+            <a:r>
+              <a:rPr sz="1600" dirty="0">
+                <a:solidFill>
+                  <a:schemeClr val="tx1"/>
+                </a:solidFill>
+              </a:rPr>
               <a:t>• Faculty Viva Defense: Demonstrates mastery of both Greedy &amp; DP shortest paths.</a:t>
             </a:r>
           </a:p>
@@ -3729,7 +4136,7 @@
 </file>
 
 <file path=ppt/slides/slide11.xml><?xml version="1.0" encoding="utf-8"?>
-<p:sld xmlns:a="http://schemas.openxmlformats.org/drawingml/2006/main" xmlns:p="http://schemas.openxmlformats.org/presentationml/2006/main" xmlns:r="http://schemas.openxmlformats.org/officeDocument/2006/relationships">
+<p:sld xmlns:a="http://schemas.openxmlformats.org/drawingml/2006/main" xmlns:r="http://schemas.openxmlformats.org/officeDocument/2006/relationships" xmlns:p="http://schemas.openxmlformats.org/presentationml/2006/main">
   <p:cSld>
     <p:bg>
       <p:bgPr>
@@ -3745,7 +4152,14 @@
         <p:cNvGrpSpPr/>
         <p:nvPr/>
       </p:nvGrpSpPr>
-      <p:grpSpPr/>
+      <p:grpSpPr>
+        <a:xfrm>
+          <a:off x="0" y="0"/>
+          <a:ext cx="0" cy="0"/>
+          <a:chOff x="0" y="0"/>
+          <a:chExt cx="0" cy="0"/>
+        </a:xfrm>
+      </p:grpSpPr>
       <p:pic>
         <p:nvPicPr>
           <p:cNvPr id="2" name="Picture 1" descr="system_architecture_visual.png"/>
@@ -3806,7 +4220,7 @@
           </a:fontRef>
         </p:style>
         <p:txBody>
-          <a:bodyPr rtlCol="0" anchor="ctr" wrap="none" lIns="128016" rIns="128016" tIns="36576" bIns="36576"/>
+          <a:bodyPr wrap="none" lIns="128016" tIns="36576" rIns="128016" bIns="36576" rtlCol="0" anchor="ctr"/>
           <a:lstStyle/>
           <a:p>
             <a:pPr algn="ctr">
@@ -3895,14 +4309,6 @@
           </a:p>
           <a:p>
             <a:br/>
-            <a:pPr>
-              <a:defRPr sz="1300" b="1">
-                <a:solidFill>
-                  <a:srgbClr val="241C1C"/>
-                </a:solidFill>
-                <a:latin typeface="Inter"/>
-              </a:defRPr>
-            </a:pPr>
             <a:r>
               <a:t>1. Cargo Packing Engine (Knapsack DP):</a:t>
             </a:r>
@@ -3922,14 +4328,6 @@
           </a:p>
           <a:p>
             <a:br/>
-            <a:pPr>
-              <a:defRPr sz="1300" b="1">
-                <a:solidFill>
-                  <a:srgbClr val="241C1C"/>
-                </a:solidFill>
-                <a:latin typeface="Inter"/>
-              </a:defRPr>
-            </a:pPr>
             <a:r>
               <a:t>2. Spatial Routing Engine (Dijkstra Min-Heap):</a:t>
             </a:r>
@@ -3949,14 +4347,6 @@
           </a:p>
           <a:p>
             <a:br/>
-            <a:pPr>
-              <a:defRPr sz="1300" b="1">
-                <a:solidFill>
-                  <a:srgbClr val="241C1C"/>
-                </a:solidFill>
-                <a:latin typeface="Inter"/>
-              </a:defRPr>
-            </a:pPr>
             <a:r>
               <a:t>3. Congestion &amp; Penalty Auditor (Bellman-Ford):</a:t>
             </a:r>
@@ -3976,14 +4366,6 @@
           </a:p>
           <a:p>
             <a:br/>
-            <a:pPr>
-              <a:defRPr sz="1300" b="1">
-                <a:solidFill>
-                  <a:srgbClr val="241C1C"/>
-                </a:solidFill>
-                <a:latin typeface="Inter"/>
-              </a:defRPr>
-            </a:pPr>
             <a:r>
               <a:t>4. Operations Dashboard &amp; Viva Labs:</a:t>
             </a:r>
@@ -4012,7 +4394,7 @@
 </file>
 
 <file path=ppt/slides/slide12.xml><?xml version="1.0" encoding="utf-8"?>
-<p:sld xmlns:a="http://schemas.openxmlformats.org/drawingml/2006/main" xmlns:p="http://schemas.openxmlformats.org/presentationml/2006/main" xmlns:r="http://schemas.openxmlformats.org/officeDocument/2006/relationships">
+<p:sld xmlns:a="http://schemas.openxmlformats.org/drawingml/2006/main" xmlns:r="http://schemas.openxmlformats.org/officeDocument/2006/relationships" xmlns:p="http://schemas.openxmlformats.org/presentationml/2006/main">
   <p:cSld>
     <p:bg>
       <p:bgPr>
@@ -4028,7 +4410,14 @@
         <p:cNvGrpSpPr/>
         <p:nvPr/>
       </p:nvGrpSpPr>
-      <p:grpSpPr/>
+      <p:grpSpPr>
+        <a:xfrm>
+          <a:off x="0" y="0"/>
+          <a:ext cx="0" cy="0"/>
+          <a:chOff x="0" y="0"/>
+          <a:chExt cx="0" cy="0"/>
+        </a:xfrm>
+      </p:grpSpPr>
       <p:sp>
         <p:nvSpPr>
           <p:cNvPr id="2" name="Rounded Rectangle 1"/>
@@ -4065,7 +4454,7 @@
           </a:fontRef>
         </p:style>
         <p:txBody>
-          <a:bodyPr rtlCol="0" anchor="ctr" wrap="none" lIns="128016" rIns="128016" tIns="36576" bIns="36576"/>
+          <a:bodyPr wrap="none" lIns="128016" tIns="36576" rIns="128016" bIns="36576" rtlCol="0" anchor="ctr"/>
           <a:lstStyle/>
           <a:p>
             <a:pPr algn="ctr">
@@ -4160,6 +4549,7 @@
           <a:lstStyle/>
           <a:p>
             <a:pPr algn="ctr"/>
+            <a:endParaRPr/>
           </a:p>
         </p:txBody>
       </p:sp>
@@ -4278,6 +4668,7 @@
           <a:lstStyle/>
           <a:p>
             <a:pPr algn="ctr"/>
+            <a:endParaRPr/>
           </a:p>
         </p:txBody>
       </p:sp>
@@ -4363,7 +4754,7 @@
 </file>
 
 <file path=ppt/slides/slide13.xml><?xml version="1.0" encoding="utf-8"?>
-<p:sld xmlns:a="http://schemas.openxmlformats.org/drawingml/2006/main" xmlns:p="http://schemas.openxmlformats.org/presentationml/2006/main" xmlns:r="http://schemas.openxmlformats.org/officeDocument/2006/relationships">
+<p:sld xmlns:a="http://schemas.openxmlformats.org/drawingml/2006/main" xmlns:r="http://schemas.openxmlformats.org/officeDocument/2006/relationships" xmlns:p="http://schemas.openxmlformats.org/presentationml/2006/main">
   <p:cSld>
     <p:bg>
       <p:bgPr>
@@ -4379,7 +4770,14 @@
         <p:cNvGrpSpPr/>
         <p:nvPr/>
       </p:nvGrpSpPr>
-      <p:grpSpPr/>
+      <p:grpSpPr>
+        <a:xfrm>
+          <a:off x="0" y="0"/>
+          <a:ext cx="0" cy="0"/>
+          <a:chOff x="0" y="0"/>
+          <a:chExt cx="0" cy="0"/>
+        </a:xfrm>
+      </p:grpSpPr>
       <p:sp>
         <p:nvSpPr>
           <p:cNvPr id="2" name="Rounded Rectangle 1"/>
@@ -4416,7 +4814,7 @@
           </a:fontRef>
         </p:style>
         <p:txBody>
-          <a:bodyPr rtlCol="0" anchor="ctr" wrap="none" lIns="128016" rIns="128016" tIns="36576" bIns="36576"/>
+          <a:bodyPr wrap="none" lIns="128016" tIns="36576" rIns="128016" bIns="36576" rtlCol="0" anchor="ctr"/>
           <a:lstStyle/>
           <a:p>
             <a:pPr algn="ctr">
@@ -4511,6 +4909,7 @@
           <a:lstStyle/>
           <a:p>
             <a:pPr algn="ctr"/>
+            <a:endParaRPr/>
           </a:p>
         </p:txBody>
       </p:sp>
@@ -4629,6 +5028,7 @@
           <a:lstStyle/>
           <a:p>
             <a:pPr algn="ctr"/>
+            <a:endParaRPr/>
           </a:p>
         </p:txBody>
       </p:sp>
@@ -4714,7 +5114,7 @@
 </file>
 
 <file path=ppt/slides/slide14.xml><?xml version="1.0" encoding="utf-8"?>
-<p:sld xmlns:a="http://schemas.openxmlformats.org/drawingml/2006/main" xmlns:p="http://schemas.openxmlformats.org/presentationml/2006/main" xmlns:r="http://schemas.openxmlformats.org/officeDocument/2006/relationships">
+<p:sld xmlns:a="http://schemas.openxmlformats.org/drawingml/2006/main" xmlns:r="http://schemas.openxmlformats.org/officeDocument/2006/relationships" xmlns:p="http://schemas.openxmlformats.org/presentationml/2006/main">
   <p:cSld>
     <p:bg>
       <p:bgPr>
@@ -4730,7 +5130,14 @@
         <p:cNvGrpSpPr/>
         <p:nvPr/>
       </p:nvGrpSpPr>
-      <p:grpSpPr/>
+      <p:grpSpPr>
+        <a:xfrm>
+          <a:off x="0" y="0"/>
+          <a:ext cx="0" cy="0"/>
+          <a:chOff x="0" y="0"/>
+          <a:chExt cx="0" cy="0"/>
+        </a:xfrm>
+      </p:grpSpPr>
       <p:sp>
         <p:nvSpPr>
           <p:cNvPr id="2" name="Rounded Rectangle 1"/>
@@ -4767,7 +5174,7 @@
           </a:fontRef>
         </p:style>
         <p:txBody>
-          <a:bodyPr rtlCol="0" anchor="ctr" wrap="none" lIns="128016" rIns="128016" tIns="36576" bIns="36576"/>
+          <a:bodyPr wrap="none" lIns="128016" tIns="36576" rIns="128016" bIns="36576" rtlCol="0" anchor="ctr"/>
           <a:lstStyle/>
           <a:p>
             <a:pPr algn="ctr">
@@ -4862,6 +5269,7 @@
           <a:lstStyle/>
           <a:p>
             <a:pPr algn="ctr"/>
+            <a:endParaRPr/>
           </a:p>
         </p:txBody>
       </p:sp>
@@ -4884,13 +5292,55 @@
                 <a:tableStyleId>{5C22544A-7EE6-4342-B048-85BDC9FD1C3A}</a:tableStyleId>
               </a:tblPr>
               <a:tblGrid>
-                <a:gridCol w="2011680"/>
-                <a:gridCol w="1280160"/>
-                <a:gridCol w="1463040"/>
-                <a:gridCol w="1188720"/>
-                <a:gridCol w="1463040"/>
-                <a:gridCol w="1097280"/>
-                <a:gridCol w="1828800"/>
+                <a:gridCol w="2011680">
+                  <a:extLst>
+                    <a:ext uri="{9D8B030D-6E8A-4147-A177-3AD203B41FA5}">
+                      <a16:colId xmlns:a16="http://schemas.microsoft.com/office/drawing/2014/main" val="20000"/>
+                    </a:ext>
+                  </a:extLst>
+                </a:gridCol>
+                <a:gridCol w="1280160">
+                  <a:extLst>
+                    <a:ext uri="{9D8B030D-6E8A-4147-A177-3AD203B41FA5}">
+                      <a16:colId xmlns:a16="http://schemas.microsoft.com/office/drawing/2014/main" val="20001"/>
+                    </a:ext>
+                  </a:extLst>
+                </a:gridCol>
+                <a:gridCol w="1463040">
+                  <a:extLst>
+                    <a:ext uri="{9D8B030D-6E8A-4147-A177-3AD203B41FA5}">
+                      <a16:colId xmlns:a16="http://schemas.microsoft.com/office/drawing/2014/main" val="20002"/>
+                    </a:ext>
+                  </a:extLst>
+                </a:gridCol>
+                <a:gridCol w="1188720">
+                  <a:extLst>
+                    <a:ext uri="{9D8B030D-6E8A-4147-A177-3AD203B41FA5}">
+                      <a16:colId xmlns:a16="http://schemas.microsoft.com/office/drawing/2014/main" val="20003"/>
+                    </a:ext>
+                  </a:extLst>
+                </a:gridCol>
+                <a:gridCol w="1463040">
+                  <a:extLst>
+                    <a:ext uri="{9D8B030D-6E8A-4147-A177-3AD203B41FA5}">
+                      <a16:colId xmlns:a16="http://schemas.microsoft.com/office/drawing/2014/main" val="20004"/>
+                    </a:ext>
+                  </a:extLst>
+                </a:gridCol>
+                <a:gridCol w="1097280">
+                  <a:extLst>
+                    <a:ext uri="{9D8B030D-6E8A-4147-A177-3AD203B41FA5}">
+                      <a16:colId xmlns:a16="http://schemas.microsoft.com/office/drawing/2014/main" val="20005"/>
+                    </a:ext>
+                  </a:extLst>
+                </a:gridCol>
+                <a:gridCol w="1828800">
+                  <a:extLst>
+                    <a:ext uri="{9D8B030D-6E8A-4147-A177-3AD203B41FA5}">
+                      <a16:colId xmlns:a16="http://schemas.microsoft.com/office/drawing/2014/main" val="20006"/>
+                    </a:ext>
+                  </a:extLst>
+                </a:gridCol>
               </a:tblGrid>
               <a:tr h="701040">
                 <a:tc>
@@ -5061,6 +5511,11 @@
                     </a:solidFill>
                   </a:tcPr>
                 </a:tc>
+                <a:extLst>
+                  <a:ext uri="{0D108BD9-81ED-4DB2-BD59-A6C34878D82A}">
+                    <a16:rowId xmlns:a16="http://schemas.microsoft.com/office/drawing/2014/main" val="10000"/>
+                  </a:ext>
+                </a:extLst>
               </a:tr>
               <a:tr h="701040">
                 <a:tc>
@@ -5231,6 +5686,11 @@
                     </a:solidFill>
                   </a:tcPr>
                 </a:tc>
+                <a:extLst>
+                  <a:ext uri="{0D108BD9-81ED-4DB2-BD59-A6C34878D82A}">
+                    <a16:rowId xmlns:a16="http://schemas.microsoft.com/office/drawing/2014/main" val="10001"/>
+                  </a:ext>
+                </a:extLst>
               </a:tr>
               <a:tr h="701040">
                 <a:tc>
@@ -5401,6 +5861,11 @@
                     </a:solidFill>
                   </a:tcPr>
                 </a:tc>
+                <a:extLst>
+                  <a:ext uri="{0D108BD9-81ED-4DB2-BD59-A6C34878D82A}">
+                    <a16:rowId xmlns:a16="http://schemas.microsoft.com/office/drawing/2014/main" val="10002"/>
+                  </a:ext>
+                </a:extLst>
               </a:tr>
               <a:tr h="701040">
                 <a:tc>
@@ -5571,6 +6036,11 @@
                     </a:solidFill>
                   </a:tcPr>
                 </a:tc>
+                <a:extLst>
+                  <a:ext uri="{0D108BD9-81ED-4DB2-BD59-A6C34878D82A}">
+                    <a16:rowId xmlns:a16="http://schemas.microsoft.com/office/drawing/2014/main" val="10003"/>
+                  </a:ext>
+                </a:extLst>
               </a:tr>
               <a:tr h="701040">
                 <a:tc>
@@ -5741,6 +6211,11 @@
                     </a:solidFill>
                   </a:tcPr>
                 </a:tc>
+                <a:extLst>
+                  <a:ext uri="{0D108BD9-81ED-4DB2-BD59-A6C34878D82A}">
+                    <a16:rowId xmlns:a16="http://schemas.microsoft.com/office/drawing/2014/main" val="10004"/>
+                  </a:ext>
+                </a:extLst>
               </a:tr>
               <a:tr h="701040">
                 <a:tc>
@@ -5911,6 +6386,11 @@
                     </a:solidFill>
                   </a:tcPr>
                 </a:tc>
+                <a:extLst>
+                  <a:ext uri="{0D108BD9-81ED-4DB2-BD59-A6C34878D82A}">
+                    <a16:rowId xmlns:a16="http://schemas.microsoft.com/office/drawing/2014/main" val="10005"/>
+                  </a:ext>
+                </a:extLst>
               </a:tr>
             </a:tbl>
           </a:graphicData>
@@ -5925,7 +6405,7 @@
 </file>
 
 <file path=ppt/slides/slide15.xml><?xml version="1.0" encoding="utf-8"?>
-<p:sld xmlns:a="http://schemas.openxmlformats.org/drawingml/2006/main" xmlns:p="http://schemas.openxmlformats.org/presentationml/2006/main" xmlns:r="http://schemas.openxmlformats.org/officeDocument/2006/relationships">
+<p:sld xmlns:a="http://schemas.openxmlformats.org/drawingml/2006/main" xmlns:r="http://schemas.openxmlformats.org/officeDocument/2006/relationships" xmlns:p="http://schemas.openxmlformats.org/presentationml/2006/main">
   <p:cSld>
     <p:bg>
       <p:bgPr>
@@ -5941,7 +6421,14 @@
         <p:cNvGrpSpPr/>
         <p:nvPr/>
       </p:nvGrpSpPr>
-      <p:grpSpPr/>
+      <p:grpSpPr>
+        <a:xfrm>
+          <a:off x="0" y="0"/>
+          <a:ext cx="0" cy="0"/>
+          <a:chOff x="0" y="0"/>
+          <a:chExt cx="0" cy="0"/>
+        </a:xfrm>
+      </p:grpSpPr>
       <p:sp>
         <p:nvSpPr>
           <p:cNvPr id="2" name="Rounded Rectangle 1"/>
@@ -5978,7 +6465,7 @@
           </a:fontRef>
         </p:style>
         <p:txBody>
-          <a:bodyPr rtlCol="0" anchor="ctr" wrap="none" lIns="128016" rIns="128016" tIns="36576" bIns="36576"/>
+          <a:bodyPr wrap="none" lIns="128016" tIns="36576" rIns="128016" bIns="36576" rtlCol="0" anchor="ctr"/>
           <a:lstStyle/>
           <a:p>
             <a:pPr algn="ctr">
@@ -6259,7 +6746,7 @@
 </file>
 
 <file path=ppt/slides/slide16.xml><?xml version="1.0" encoding="utf-8"?>
-<p:sld xmlns:a="http://schemas.openxmlformats.org/drawingml/2006/main" xmlns:p="http://schemas.openxmlformats.org/presentationml/2006/main" xmlns:r="http://schemas.openxmlformats.org/officeDocument/2006/relationships">
+<p:sld xmlns:a="http://schemas.openxmlformats.org/drawingml/2006/main" xmlns:r="http://schemas.openxmlformats.org/officeDocument/2006/relationships" xmlns:p="http://schemas.openxmlformats.org/presentationml/2006/main">
   <p:cSld>
     <p:bg>
       <p:bgPr>
@@ -6275,7 +6762,14 @@
         <p:cNvGrpSpPr/>
         <p:nvPr/>
       </p:nvGrpSpPr>
-      <p:grpSpPr/>
+      <p:grpSpPr>
+        <a:xfrm>
+          <a:off x="0" y="0"/>
+          <a:ext cx="0" cy="0"/>
+          <a:chOff x="0" y="0"/>
+          <a:chExt cx="0" cy="0"/>
+        </a:xfrm>
+      </p:grpSpPr>
       <p:sp>
         <p:nvSpPr>
           <p:cNvPr id="2" name="Rounded Rectangle 1"/>
@@ -6284,8 +6778,8 @@
         </p:nvSpPr>
         <p:spPr>
           <a:xfrm>
-            <a:off x="731520" y="594360"/>
-            <a:ext cx="4114800" cy="5623560"/>
+            <a:off x="3379027" y="258901"/>
+            <a:ext cx="4114800" cy="2520980"/>
           </a:xfrm>
           <a:prstGeom prst="roundRect">
             <a:avLst/>
@@ -6318,33 +6812,10 @@
           <a:lstStyle/>
           <a:p>
             <a:pPr algn="ctr"/>
-          </a:p>
-        </p:txBody>
-      </p:sp>
-      <p:pic>
-        <p:nvPicPr>
-          <p:cNvPr id="3" name="Picture 2" descr="viva_guide.png"/>
-          <p:cNvPicPr>
-            <a:picLocks noChangeAspect="1"/>
-          </p:cNvPicPr>
-          <p:nvPr/>
-        </p:nvPicPr>
-        <p:blipFill>
-          <a:blip r:embed="rId2"/>
-          <a:stretch>
-            <a:fillRect/>
-          </a:stretch>
-        </p:blipFill>
-        <p:spPr>
-          <a:xfrm>
-            <a:off x="914400" y="777240"/>
-            <a:ext cx="3749039" cy="5257800"/>
-          </a:xfrm>
-          <a:prstGeom prst="rect">
-            <a:avLst/>
-          </a:prstGeom>
-        </p:spPr>
-      </p:pic>
+            <a:endParaRPr/>
+          </a:p>
+        </p:txBody>
+      </p:sp>
       <p:sp>
         <p:nvSpPr>
           <p:cNvPr id="4" name="Rounded Rectangle 3"/>
@@ -6353,7 +6824,7 @@
         </p:nvSpPr>
         <p:spPr>
           <a:xfrm>
-            <a:off x="5212080" y="594360"/>
+            <a:off x="3881947" y="826683"/>
             <a:ext cx="3108960" cy="384048"/>
           </a:xfrm>
           <a:prstGeom prst="roundRect">
@@ -6381,7 +6852,7 @@
           </a:fontRef>
         </p:style>
         <p:txBody>
-          <a:bodyPr rtlCol="0" anchor="ctr" wrap="none" lIns="128016" rIns="128016" tIns="36576" bIns="36576"/>
+          <a:bodyPr wrap="none" lIns="128016" tIns="36576" rIns="128016" bIns="36576" rtlCol="0" anchor="ctr"/>
           <a:lstStyle/>
           <a:p>
             <a:pPr algn="ctr">
@@ -6393,6 +6864,7 @@
               </a:defRPr>
             </a:pPr>
             <a:r>
+              <a:rPr dirty="0"/>
               <a:t>PROJECT ATTRIBUTION &amp; CREDITS</a:t>
             </a:r>
           </a:p>
@@ -6406,7 +6878,7 @@
         </p:nvSpPr>
         <p:spPr>
           <a:xfrm>
-            <a:off x="5212080" y="1097280"/>
+            <a:off x="3594868" y="1437522"/>
             <a:ext cx="6217920" cy="731520"/>
           </a:xfrm>
           <a:prstGeom prst="rect">
@@ -6429,6 +6901,7 @@
               </a:defRPr>
             </a:pPr>
             <a:r>
+              <a:rPr dirty="0"/>
               <a:t>PROJECT CREDITS</a:t>
             </a:r>
           </a:p>
@@ -6442,8 +6915,8 @@
         </p:nvSpPr>
         <p:spPr>
           <a:xfrm>
-            <a:off x="5212080" y="2011680"/>
-            <a:ext cx="6217920" cy="4206240"/>
+            <a:off x="969688" y="3429000"/>
+            <a:ext cx="9620339" cy="3170099"/>
           </a:xfrm>
           <a:prstGeom prst="rect">
             <a:avLst/>
@@ -6465,6 +6938,7 @@
               </a:defRPr>
             </a:pPr>
             <a:r>
+              <a:rPr sz="2000" dirty="0"/>
               <a:t>COURSE INSTRUCTOR &amp; MENTOR:</a:t>
             </a:r>
           </a:p>
@@ -6478,6 +6952,7 @@
               </a:defRPr>
             </a:pPr>
             <a:r>
+              <a:rPr sz="2000" dirty="0"/>
               <a:t>Dr. Syed Javed Pasha</a:t>
             </a:r>
           </a:p>
@@ -6491,13 +6966,24 @@
               </a:defRPr>
             </a:pPr>
             <a:r>
+              <a:rPr sz="2000" dirty="0"/>
               <a:t>Course Coordinator &amp; Project Mentor • Department of Computer Science &amp; Engineering</a:t>
             </a:r>
-            <a:br/>
-            <a:r>
-              <a:t>Woxsen University, School of Technology</a:t>
-            </a:r>
-            <a:br/>
+            <a:br>
+              <a:rPr sz="2000" dirty="0"/>
+            </a:br>
+            <a:r>
+              <a:rPr sz="2000" dirty="0" err="1"/>
+              <a:t>Woxsen</a:t>
+            </a:r>
+            <a:r>
+              <a:rPr sz="2000" dirty="0"/>
+              <a:t> University, School of Technology</a:t>
+            </a:r>
+            <a:br>
+              <a:rPr sz="2000" dirty="0"/>
+            </a:br>
+            <a:endParaRPr sz="2000" dirty="0"/>
           </a:p>
           <a:p>
             <a:pPr>
@@ -6509,6 +6995,7 @@
               </a:defRPr>
             </a:pPr>
             <a:r>
+              <a:rPr sz="2000" dirty="0"/>
               <a:t>STUDENT PROJECT TEAM:</a:t>
             </a:r>
           </a:p>
@@ -6522,6 +7009,7 @@
               </a:defRPr>
             </a:pPr>
             <a:r>
+              <a:rPr sz="2000" dirty="0"/>
               <a:t>• Himanshu Pandit  —  Lead System Architect &amp; Algorithm Engineer</a:t>
             </a:r>
           </a:p>
@@ -6535,6 +7023,7 @@
               </a:defRPr>
             </a:pPr>
             <a:r>
+              <a:rPr sz="2000" dirty="0"/>
               <a:t>• Devyani Pawar  —  Graph &amp; Network Modeling Specialist</a:t>
             </a:r>
           </a:p>
@@ -6548,6 +7037,7 @@
               </a:defRPr>
             </a:pPr>
             <a:r>
+              <a:rPr sz="2000" dirty="0"/>
               <a:t>• Heman  —  Dynamic Programming &amp; Benchmark Developer</a:t>
             </a:r>
           </a:p>
@@ -6561,6 +7051,7 @@
               </a:defRPr>
             </a:pPr>
             <a:r>
+              <a:rPr sz="2000" dirty="0"/>
               <a:t>• Rimika Jain  —  Heuristic Optimization &amp; UI Integration</a:t>
             </a:r>
           </a:p>
@@ -6575,7 +7066,7 @@
 </file>
 
 <file path=ppt/slides/slide17.xml><?xml version="1.0" encoding="utf-8"?>
-<p:sld xmlns:a="http://schemas.openxmlformats.org/drawingml/2006/main" xmlns:p="http://schemas.openxmlformats.org/presentationml/2006/main" xmlns:r="http://schemas.openxmlformats.org/officeDocument/2006/relationships">
+<p:sld xmlns:a="http://schemas.openxmlformats.org/drawingml/2006/main" xmlns:r="http://schemas.openxmlformats.org/officeDocument/2006/relationships" xmlns:p="http://schemas.openxmlformats.org/presentationml/2006/main">
   <p:cSld>
     <p:bg>
       <p:bgPr>
@@ -6591,7 +7082,14 @@
         <p:cNvGrpSpPr/>
         <p:nvPr/>
       </p:nvGrpSpPr>
-      <p:grpSpPr/>
+      <p:grpSpPr>
+        <a:xfrm>
+          <a:off x="0" y="0"/>
+          <a:ext cx="0" cy="0"/>
+          <a:chOff x="0" y="0"/>
+          <a:chExt cx="0" cy="0"/>
+        </a:xfrm>
+      </p:grpSpPr>
       <p:sp>
         <p:nvSpPr>
           <p:cNvPr id="2" name="TextBox 1"/>
@@ -6724,7 +7222,7 @@
           </a:fontRef>
         </p:style>
         <p:txBody>
-          <a:bodyPr rtlCol="0" anchor="ctr" wrap="none" lIns="128016" rIns="128016" tIns="36576" bIns="36576"/>
+          <a:bodyPr wrap="none" lIns="128016" tIns="36576" rIns="128016" bIns="36576" rtlCol="0" anchor="ctr"/>
           <a:lstStyle/>
           <a:p>
             <a:pPr algn="ctr">
@@ -6786,7 +7284,7 @@
 </file>
 
 <file path=ppt/slides/slide2.xml><?xml version="1.0" encoding="utf-8"?>
-<p:sld xmlns:a="http://schemas.openxmlformats.org/drawingml/2006/main" xmlns:p="http://schemas.openxmlformats.org/presentationml/2006/main" xmlns:r="http://schemas.openxmlformats.org/officeDocument/2006/relationships">
+<p:sld xmlns:a="http://schemas.openxmlformats.org/drawingml/2006/main" xmlns:r="http://schemas.openxmlformats.org/officeDocument/2006/relationships" xmlns:p="http://schemas.openxmlformats.org/presentationml/2006/main">
   <p:cSld>
     <p:bg>
       <p:bgPr>
@@ -6802,7 +7300,14 @@
         <p:cNvGrpSpPr/>
         <p:nvPr/>
       </p:nvGrpSpPr>
-      <p:grpSpPr/>
+      <p:grpSpPr>
+        <a:xfrm>
+          <a:off x="0" y="0"/>
+          <a:ext cx="0" cy="0"/>
+          <a:chOff x="0" y="0"/>
+          <a:chExt cx="0" cy="0"/>
+        </a:xfrm>
+      </p:grpSpPr>
       <p:pic>
         <p:nvPicPr>
           <p:cNvPr id="2" name="Picture 1" descr="agenda_roadmap_visual.png"/>
@@ -6899,7 +7404,7 @@
           </a:fontRef>
         </p:style>
         <p:txBody>
-          <a:bodyPr rtlCol="0" anchor="ctr" wrap="none"/>
+          <a:bodyPr wrap="none" rtlCol="0" anchor="ctr"/>
           <a:lstStyle/>
           <a:p>
             <a:pPr algn="ctr">
@@ -7001,7 +7506,7 @@
           </a:fontRef>
         </p:style>
         <p:txBody>
-          <a:bodyPr rtlCol="0" anchor="ctr" wrap="none"/>
+          <a:bodyPr wrap="none" rtlCol="0" anchor="ctr"/>
           <a:lstStyle/>
           <a:p>
             <a:pPr algn="ctr">
@@ -7103,7 +7608,7 @@
           </a:fontRef>
         </p:style>
         <p:txBody>
-          <a:bodyPr rtlCol="0" anchor="ctr" wrap="none"/>
+          <a:bodyPr wrap="none" rtlCol="0" anchor="ctr"/>
           <a:lstStyle/>
           <a:p>
             <a:pPr algn="ctr">
@@ -7205,7 +7710,7 @@
           </a:fontRef>
         </p:style>
         <p:txBody>
-          <a:bodyPr rtlCol="0" anchor="ctr" wrap="none"/>
+          <a:bodyPr wrap="none" rtlCol="0" anchor="ctr"/>
           <a:lstStyle/>
           <a:p>
             <a:pPr algn="ctr">
@@ -7307,7 +7812,7 @@
           </a:fontRef>
         </p:style>
         <p:txBody>
-          <a:bodyPr rtlCol="0" anchor="ctr" wrap="none"/>
+          <a:bodyPr wrap="none" rtlCol="0" anchor="ctr"/>
           <a:lstStyle/>
           <a:p>
             <a:pPr algn="ctr">
@@ -7409,7 +7914,7 @@
           </a:fontRef>
         </p:style>
         <p:txBody>
-          <a:bodyPr rtlCol="0" anchor="ctr" wrap="none"/>
+          <a:bodyPr wrap="none" rtlCol="0" anchor="ctr"/>
           <a:lstStyle/>
           <a:p>
             <a:pPr algn="ctr">
@@ -7484,7 +7989,7 @@
 </file>
 
 <file path=ppt/slides/slide3.xml><?xml version="1.0" encoding="utf-8"?>
-<p:sld xmlns:a="http://schemas.openxmlformats.org/drawingml/2006/main" xmlns:p="http://schemas.openxmlformats.org/presentationml/2006/main" xmlns:r="http://schemas.openxmlformats.org/officeDocument/2006/relationships">
+<p:sld xmlns:a="http://schemas.openxmlformats.org/drawingml/2006/main" xmlns:r="http://schemas.openxmlformats.org/officeDocument/2006/relationships" xmlns:p="http://schemas.openxmlformats.org/presentationml/2006/main">
   <p:cSld>
     <p:bg>
       <p:bgPr>
@@ -7500,7 +8005,14 @@
         <p:cNvGrpSpPr/>
         <p:nvPr/>
       </p:nvGrpSpPr>
-      <p:grpSpPr/>
+      <p:grpSpPr>
+        <a:xfrm>
+          <a:off x="0" y="0"/>
+          <a:ext cx="0" cy="0"/>
+          <a:chOff x="0" y="0"/>
+          <a:chExt cx="0" cy="0"/>
+        </a:xfrm>
+      </p:grpSpPr>
       <p:sp>
         <p:nvSpPr>
           <p:cNvPr id="2" name="Rounded Rectangle 1"/>
@@ -7537,7 +8049,7 @@
           </a:fontRef>
         </p:style>
         <p:txBody>
-          <a:bodyPr rtlCol="0" anchor="ctr" wrap="none" lIns="128016" rIns="128016" tIns="36576" bIns="36576"/>
+          <a:bodyPr wrap="none" lIns="128016" tIns="36576" rIns="128016" bIns="36576" rtlCol="0" anchor="ctr"/>
           <a:lstStyle/>
           <a:p>
             <a:pPr algn="ctr">
@@ -7626,14 +8138,6 @@
           </a:p>
           <a:p>
             <a:br/>
-            <a:pPr>
-              <a:defRPr sz="1300" b="1">
-                <a:solidFill>
-                  <a:srgbClr val="241C1C"/>
-                </a:solidFill>
-                <a:latin typeface="Inter"/>
-              </a:defRPr>
-            </a:pPr>
             <a:r>
               <a:t>• Last-Mile Significance:</a:t>
             </a:r>
@@ -7653,14 +8157,6 @@
           </a:p>
           <a:p>
             <a:br/>
-            <a:pPr>
-              <a:defRPr sz="1300" b="1">
-                <a:solidFill>
-                  <a:srgbClr val="241C1C"/>
-                </a:solidFill>
-                <a:latin typeface="Inter"/>
-              </a:defRPr>
-            </a:pPr>
             <a:r>
               <a:t>• Real-World Complexity:</a:t>
             </a:r>
@@ -7680,14 +8176,6 @@
           </a:p>
           <a:p>
             <a:br/>
-            <a:pPr>
-              <a:defRPr sz="1300" b="1">
-                <a:solidFill>
-                  <a:srgbClr val="241C1C"/>
-                </a:solidFill>
-                <a:latin typeface="Inter"/>
-              </a:defRPr>
-            </a:pPr>
             <a:r>
               <a:t>• Academic Focus:</a:t>
             </a:r>
@@ -7707,14 +8195,6 @@
           </a:p>
           <a:p>
             <a:br/>
-            <a:pPr>
-              <a:defRPr sz="1300" b="1">
-                <a:solidFill>
-                  <a:srgbClr val="241C1C"/>
-                </a:solidFill>
-                <a:latin typeface="Inter"/>
-              </a:defRPr>
-            </a:pPr>
             <a:r>
               <a:t>• Production Deliverable:</a:t>
             </a:r>
@@ -7776,6 +8256,7 @@
           <a:lstStyle/>
           <a:p>
             <a:pPr algn="ctr"/>
+            <a:endParaRPr/>
           </a:p>
         </p:txBody>
       </p:sp>
@@ -7848,7 +8329,7 @@
 </file>
 
 <file path=ppt/slides/slide4.xml><?xml version="1.0" encoding="utf-8"?>
-<p:sld xmlns:a="http://schemas.openxmlformats.org/drawingml/2006/main" xmlns:p="http://schemas.openxmlformats.org/presentationml/2006/main" xmlns:r="http://schemas.openxmlformats.org/officeDocument/2006/relationships">
+<p:sld xmlns:a="http://schemas.openxmlformats.org/drawingml/2006/main" xmlns:r="http://schemas.openxmlformats.org/officeDocument/2006/relationships" xmlns:p="http://schemas.openxmlformats.org/presentationml/2006/main">
   <p:cSld>
     <p:bg>
       <p:bgPr>
@@ -7864,7 +8345,14 @@
         <p:cNvGrpSpPr/>
         <p:nvPr/>
       </p:nvGrpSpPr>
-      <p:grpSpPr/>
+      <p:grpSpPr>
+        <a:xfrm>
+          <a:off x="0" y="0"/>
+          <a:ext cx="0" cy="0"/>
+          <a:chOff x="0" y="0"/>
+          <a:chExt cx="0" cy="0"/>
+        </a:xfrm>
+      </p:grpSpPr>
       <p:sp>
         <p:nvSpPr>
           <p:cNvPr id="2" name="Rounded Rectangle 1"/>
@@ -7901,7 +8389,7 @@
           </a:fontRef>
         </p:style>
         <p:txBody>
-          <a:bodyPr rtlCol="0" anchor="ctr" wrap="none" lIns="128016" rIns="128016" tIns="36576" bIns="36576"/>
+          <a:bodyPr wrap="none" lIns="128016" tIns="36576" rIns="128016" bIns="36576" rtlCol="0" anchor="ctr"/>
           <a:lstStyle/>
           <a:p>
             <a:pPr algn="ctr">
@@ -7992,7 +8480,7 @@
           </a:fontRef>
         </p:style>
         <p:txBody>
-          <a:bodyPr rtlCol="0" anchor="ctr" wrap="square" lIns="164592" rIns="164592" tIns="201168"/>
+          <a:bodyPr wrap="square" lIns="164592" tIns="201168" rIns="164592" rtlCol="0" anchor="ctr"/>
           <a:lstStyle/>
           <a:p>
             <a:pPr algn="ctr">
@@ -8004,6 +8492,7 @@
               </a:defRPr>
             </a:pPr>
             <a:r>
+              <a:rPr dirty="0"/>
               <a:t>01. KNAPSACK (DP)</a:t>
             </a:r>
           </a:p>
@@ -8017,6 +8506,7 @@
               </a:defRPr>
             </a:pPr>
             <a:r>
+              <a:rPr dirty="0"/>
               <a:t>Complexity: O(n · W) Pseudo-poly</a:t>
             </a:r>
           </a:p>
@@ -8030,28 +8520,70 @@
               </a:defRPr>
             </a:pPr>
             <a:r>
+              <a:rPr dirty="0"/>
               <a:t>Paradigm: Global Optimum</a:t>
             </a:r>
           </a:p>
           <a:p>
-            <a:br/>
-            <a:pPr>
-              <a:defRPr sz="1200">
-                <a:solidFill>
-                  <a:srgbClr val="241C1C"/>
-                </a:solidFill>
-                <a:latin typeface="Inter"/>
-              </a:defRPr>
-            </a:pPr>
-            <a:r>
+            <a:br>
+              <a:rPr dirty="0">
+                <a:solidFill>
+                  <a:schemeClr val="tx1"/>
+                </a:solidFill>
+              </a:rPr>
+            </a:br>
+            <a:r>
+              <a:rPr dirty="0">
+                <a:solidFill>
+                  <a:schemeClr val="tx1"/>
+                </a:solidFill>
+              </a:rPr>
               <a:t>• Solves discrete 0/1 order selection within payload limit W.</a:t>
             </a:r>
-            <a:br/>
-            <a:r>
-              <a:t>• 2D memoization table guarantees zero wasted space.</a:t>
-            </a:r>
-            <a:br/>
-            <a:r>
+            <a:br>
+              <a:rPr dirty="0">
+                <a:solidFill>
+                  <a:schemeClr val="tx1"/>
+                </a:solidFill>
+              </a:rPr>
+            </a:br>
+            <a:r>
+              <a:rPr dirty="0">
+                <a:solidFill>
+                  <a:schemeClr val="tx1"/>
+                </a:solidFill>
+              </a:rPr>
+              <a:t>• 2D </a:t>
+            </a:r>
+            <a:r>
+              <a:rPr dirty="0" err="1">
+                <a:solidFill>
+                  <a:schemeClr val="tx1"/>
+                </a:solidFill>
+              </a:rPr>
+              <a:t>memoization</a:t>
+            </a:r>
+            <a:r>
+              <a:rPr dirty="0">
+                <a:solidFill>
+                  <a:schemeClr val="tx1"/>
+                </a:solidFill>
+              </a:rPr>
+              <a:t> table guarantees zero wasted space.</a:t>
+            </a:r>
+            <a:br>
+              <a:rPr dirty="0">
+                <a:solidFill>
+                  <a:schemeClr val="tx1"/>
+                </a:solidFill>
+              </a:rPr>
+            </a:br>
+            <a:r>
+              <a:rPr dirty="0">
+                <a:solidFill>
+                  <a:schemeClr val="tx1"/>
+                </a:solidFill>
+              </a:rPr>
               <a:t>• Backtracking golden trail identifies exact parcel bundle.</a:t>
             </a:r>
           </a:p>
@@ -8095,7 +8627,7 @@
           </a:fontRef>
         </p:style>
         <p:txBody>
-          <a:bodyPr rtlCol="0" anchor="ctr" wrap="square" lIns="164592" rIns="164592" tIns="201168"/>
+          <a:bodyPr wrap="square" lIns="164592" tIns="201168" rIns="164592" rtlCol="0" anchor="ctr"/>
           <a:lstStyle/>
           <a:p>
             <a:pPr algn="ctr">
@@ -8107,6 +8639,7 @@
               </a:defRPr>
             </a:pPr>
             <a:r>
+              <a:rPr dirty="0"/>
               <a:t>02. GREEDY HEURISTICS</a:t>
             </a:r>
           </a:p>
@@ -8120,6 +8653,7 @@
               </a:defRPr>
             </a:pPr>
             <a:r>
+              <a:rPr dirty="0"/>
               <a:t>Complexity: O(n log n) Sort Time</a:t>
             </a:r>
           </a:p>
@@ -8133,28 +8667,62 @@
               </a:defRPr>
             </a:pPr>
             <a:r>
+              <a:rPr dirty="0"/>
               <a:t>Paradigm: Fast Approximation</a:t>
             </a:r>
           </a:p>
           <a:p>
-            <a:br/>
-            <a:pPr>
-              <a:defRPr sz="1200">
-                <a:solidFill>
-                  <a:srgbClr val="241C1C"/>
-                </a:solidFill>
-                <a:latin typeface="Inter"/>
-              </a:defRPr>
-            </a:pPr>
-            <a:r>
+            <a:br>
+              <a:rPr dirty="0">
+                <a:solidFill>
+                  <a:schemeClr val="tx1"/>
+                </a:solidFill>
+              </a:rPr>
+            </a:br>
+            <a:r>
+              <a:rPr dirty="0">
+                <a:solidFill>
+                  <a:schemeClr val="tx1"/>
+                </a:solidFill>
+              </a:rPr>
               <a:t>• Priority sorting by Profit Density (Rs./kg), Deadline, Profit.</a:t>
             </a:r>
-            <a:br/>
-            <a:r>
-              <a:t>• Fast heuristic execution in under 0.5 ms.</a:t>
-            </a:r>
-            <a:br/>
-            <a:r>
+            <a:br>
+              <a:rPr dirty="0">
+                <a:solidFill>
+                  <a:schemeClr val="tx1"/>
+                </a:solidFill>
+              </a:rPr>
+            </a:br>
+            <a:r>
+              <a:rPr dirty="0">
+                <a:solidFill>
+                  <a:schemeClr val="tx1"/>
+                </a:solidFill>
+              </a:rPr>
+              <a:t>• Fast heuristic execution in under 0.5 </a:t>
+            </a:r>
+            <a:r>
+              <a:rPr dirty="0" err="1">
+                <a:solidFill>
+                  <a:schemeClr val="tx1"/>
+                </a:solidFill>
+              </a:rPr>
+              <a:t>ms.</a:t>
+            </a:r>
+            <a:br>
+              <a:rPr dirty="0">
+                <a:solidFill>
+                  <a:schemeClr val="tx1"/>
+                </a:solidFill>
+              </a:rPr>
+            </a:br>
+            <a:r>
+              <a:rPr dirty="0">
+                <a:solidFill>
+                  <a:schemeClr val="tx1"/>
+                </a:solidFill>
+              </a:rPr>
               <a:t>• Prone to greedy traps for integer discrete cargo.</a:t>
             </a:r>
           </a:p>
@@ -8198,7 +8766,7 @@
           </a:fontRef>
         </p:style>
         <p:txBody>
-          <a:bodyPr rtlCol="0" anchor="ctr" wrap="square" lIns="164592" rIns="164592" tIns="201168"/>
+          <a:bodyPr wrap="square" lIns="164592" tIns="201168" rIns="164592" rtlCol="0" anchor="ctr"/>
           <a:lstStyle/>
           <a:p>
             <a:pPr algn="ctr">
@@ -8210,6 +8778,7 @@
               </a:defRPr>
             </a:pPr>
             <a:r>
+              <a:rPr dirty="0"/>
               <a:t>03. DIJKSTRA SSSP</a:t>
             </a:r>
           </a:p>
@@ -8223,6 +8792,7 @@
               </a:defRPr>
             </a:pPr>
             <a:r>
+              <a:rPr dirty="0"/>
               <a:t>Complexity: O((V + E) log V)</a:t>
             </a:r>
           </a:p>
@@ -8236,28 +8806,54 @@
               </a:defRPr>
             </a:pPr>
             <a:r>
+              <a:rPr dirty="0"/>
               <a:t>Paradigm: Single-Source Shortest</a:t>
             </a:r>
           </a:p>
           <a:p>
-            <a:br/>
-            <a:pPr>
-              <a:defRPr sz="1200">
-                <a:solidFill>
-                  <a:srgbClr val="241C1C"/>
-                </a:solidFill>
-                <a:latin typeface="Inter"/>
-              </a:defRPr>
-            </a:pPr>
-            <a:r>
+            <a:br>
+              <a:rPr dirty="0">
+                <a:solidFill>
+                  <a:schemeClr val="tx1"/>
+                </a:solidFill>
+              </a:rPr>
+            </a:br>
+            <a:r>
+              <a:rPr dirty="0">
+                <a:solidFill>
+                  <a:schemeClr val="tx1"/>
+                </a:solidFill>
+              </a:rPr>
               <a:t>• Custom Binary Min-Heap Priority Queue implementation.</a:t>
             </a:r>
-            <a:br/>
-            <a:r>
+            <a:br>
+              <a:rPr dirty="0">
+                <a:solidFill>
+                  <a:schemeClr val="tx1"/>
+                </a:solidFill>
+              </a:rPr>
+            </a:br>
+            <a:r>
+              <a:rPr dirty="0">
+                <a:solidFill>
+                  <a:schemeClr val="tx1"/>
+                </a:solidFill>
+              </a:rPr>
               <a:t>• Invariant: Greedily finalizes vertex with minimum tentative dist.</a:t>
             </a:r>
-            <a:br/>
-            <a:r>
+            <a:br>
+              <a:rPr dirty="0">
+                <a:solidFill>
+                  <a:schemeClr val="tx1"/>
+                </a:solidFill>
+              </a:rPr>
+            </a:br>
+            <a:r>
+              <a:rPr dirty="0">
+                <a:solidFill>
+                  <a:schemeClr val="tx1"/>
+                </a:solidFill>
+              </a:rPr>
               <a:t>• Optimal routing across non-negative urban road networks.</a:t>
             </a:r>
           </a:p>
@@ -8301,7 +8897,7 @@
           </a:fontRef>
         </p:style>
         <p:txBody>
-          <a:bodyPr rtlCol="0" anchor="ctr" wrap="square" lIns="164592" rIns="164592" tIns="201168"/>
+          <a:bodyPr wrap="square" lIns="164592" tIns="201168" rIns="164592" rtlCol="0" anchor="ctr"/>
           <a:lstStyle/>
           <a:p>
             <a:pPr algn="ctr">
@@ -8313,6 +8909,7 @@
               </a:defRPr>
             </a:pPr>
             <a:r>
+              <a:rPr dirty="0"/>
               <a:t>04. BELLMAN-FORD</a:t>
             </a:r>
           </a:p>
@@ -8326,6 +8923,7 @@
               </a:defRPr>
             </a:pPr>
             <a:r>
+              <a:rPr dirty="0"/>
               <a:t>Complexity: O(V · E) Iterative DP</a:t>
             </a:r>
           </a:p>
@@ -8339,28 +8937,54 @@
               </a:defRPr>
             </a:pPr>
             <a:r>
+              <a:rPr dirty="0"/>
               <a:t>Paradigm: Dynamic Edge Relaxation</a:t>
             </a:r>
           </a:p>
           <a:p>
-            <a:br/>
-            <a:pPr>
-              <a:defRPr sz="1200">
-                <a:solidFill>
-                  <a:srgbClr val="241C1C"/>
-                </a:solidFill>
-                <a:latin typeface="Inter"/>
-              </a:defRPr>
-            </a:pPr>
-            <a:r>
+            <a:br>
+              <a:rPr dirty="0">
+                <a:solidFill>
+                  <a:schemeClr val="tx1"/>
+                </a:solidFill>
+              </a:rPr>
+            </a:br>
+            <a:r>
+              <a:rPr dirty="0">
+                <a:solidFill>
+                  <a:schemeClr val="tx1"/>
+                </a:solidFill>
+              </a:rPr>
               <a:t>• Relaxes all |E| edges for |V|-1 iterations.</a:t>
             </a:r>
-            <a:br/>
-            <a:r>
+            <a:br>
+              <a:rPr dirty="0">
+                <a:solidFill>
+                  <a:schemeClr val="tx1"/>
+                </a:solidFill>
+              </a:rPr>
+            </a:br>
+            <a:r>
+              <a:rPr dirty="0">
+                <a:solidFill>
+                  <a:schemeClr val="tx1"/>
+                </a:solidFill>
+              </a:rPr>
               <a:t>• Models congestion penalties, toll rebates &amp; detours.</a:t>
             </a:r>
-            <a:br/>
-            <a:r>
+            <a:br>
+              <a:rPr dirty="0">
+                <a:solidFill>
+                  <a:schemeClr val="tx1"/>
+                </a:solidFill>
+              </a:rPr>
+            </a:br>
+            <a:r>
+              <a:rPr dirty="0">
+                <a:solidFill>
+                  <a:schemeClr val="tx1"/>
+                </a:solidFill>
+              </a:rPr>
               <a:t>• Detects negative-weight loops preventing routing anomalies.</a:t>
             </a:r>
           </a:p>
@@ -8375,7 +8999,7 @@
 </file>
 
 <file path=ppt/slides/slide5.xml><?xml version="1.0" encoding="utf-8"?>
-<p:sld xmlns:a="http://schemas.openxmlformats.org/drawingml/2006/main" xmlns:p="http://schemas.openxmlformats.org/presentationml/2006/main" xmlns:r="http://schemas.openxmlformats.org/officeDocument/2006/relationships">
+<p:sld xmlns:a="http://schemas.openxmlformats.org/drawingml/2006/main" xmlns:r="http://schemas.openxmlformats.org/officeDocument/2006/relationships" xmlns:p="http://schemas.openxmlformats.org/presentationml/2006/main">
   <p:cSld>
     <p:bg>
       <p:bgPr>
@@ -8391,7 +9015,14 @@
         <p:cNvGrpSpPr/>
         <p:nvPr/>
       </p:nvGrpSpPr>
-      <p:grpSpPr/>
+      <p:grpSpPr>
+        <a:xfrm>
+          <a:off x="0" y="0"/>
+          <a:ext cx="0" cy="0"/>
+          <a:chOff x="0" y="0"/>
+          <a:chExt cx="0" cy="0"/>
+        </a:xfrm>
+      </p:grpSpPr>
       <p:pic>
         <p:nvPicPr>
           <p:cNvPr id="2" name="Picture 1" descr="urban_problem_visual.png"/>
@@ -8452,7 +9083,7 @@
           </a:fontRef>
         </p:style>
         <p:txBody>
-          <a:bodyPr rtlCol="0" anchor="ctr" wrap="none" lIns="128016" rIns="128016" tIns="36576" bIns="36576"/>
+          <a:bodyPr wrap="none" lIns="128016" tIns="36576" rIns="128016" bIns="36576" rtlCol="0" anchor="ctr"/>
           <a:lstStyle/>
           <a:p>
             <a:pPr algn="ctr">
@@ -8541,14 +9172,6 @@
           </a:p>
           <a:p>
             <a:br/>
-            <a:pPr>
-              <a:defRPr sz="1300" b="1">
-                <a:solidFill>
-                  <a:srgbClr val="241C1C"/>
-                </a:solidFill>
-                <a:latin typeface="Inter"/>
-              </a:defRPr>
-            </a:pPr>
             <a:r>
               <a:t>1. Combinatorial Cargo Explosion:</a:t>
             </a:r>
@@ -8568,14 +9191,6 @@
           </a:p>
           <a:p>
             <a:br/>
-            <a:pPr>
-              <a:defRPr sz="1300" b="1">
-                <a:solidFill>
-                  <a:srgbClr val="241C1C"/>
-                </a:solidFill>
-                <a:latin typeface="Inter"/>
-              </a:defRPr>
-            </a:pPr>
             <a:r>
               <a:t>2. Spatial Route Inefficiencies:</a:t>
             </a:r>
@@ -8595,14 +9210,6 @@
           </a:p>
           <a:p>
             <a:br/>
-            <a:pPr>
-              <a:defRPr sz="1300" b="1">
-                <a:solidFill>
-                  <a:srgbClr val="241C1C"/>
-                </a:solidFill>
-                <a:latin typeface="Inter"/>
-              </a:defRPr>
-            </a:pPr>
             <a:r>
               <a:t>3. Real-Time Operational Latency:</a:t>
             </a:r>
@@ -8631,7 +9238,7 @@
 </file>
 
 <file path=ppt/slides/slide6.xml><?xml version="1.0" encoding="utf-8"?>
-<p:sld xmlns:a="http://schemas.openxmlformats.org/drawingml/2006/main" xmlns:p="http://schemas.openxmlformats.org/presentationml/2006/main" xmlns:r="http://schemas.openxmlformats.org/officeDocument/2006/relationships">
+<p:sld xmlns:a="http://schemas.openxmlformats.org/drawingml/2006/main" xmlns:r="http://schemas.openxmlformats.org/officeDocument/2006/relationships" xmlns:p="http://schemas.openxmlformats.org/presentationml/2006/main">
   <p:cSld>
     <p:bg>
       <p:bgPr>
@@ -8647,7 +9254,14 @@
         <p:cNvGrpSpPr/>
         <p:nvPr/>
       </p:nvGrpSpPr>
-      <p:grpSpPr/>
+      <p:grpSpPr>
+        <a:xfrm>
+          <a:off x="0" y="0"/>
+          <a:ext cx="0" cy="0"/>
+          <a:chOff x="0" y="0"/>
+          <a:chExt cx="0" cy="0"/>
+        </a:xfrm>
+      </p:grpSpPr>
       <p:sp>
         <p:nvSpPr>
           <p:cNvPr id="2" name="Rounded Rectangle 1"/>
@@ -8684,7 +9298,7 @@
           </a:fontRef>
         </p:style>
         <p:txBody>
-          <a:bodyPr rtlCol="0" anchor="ctr" wrap="none" lIns="128016" rIns="128016" tIns="36576" bIns="36576"/>
+          <a:bodyPr wrap="none" lIns="128016" tIns="36576" rIns="128016" bIns="36576" rtlCol="0" anchor="ctr"/>
           <a:lstStyle/>
           <a:p>
             <a:pPr algn="ctr">
@@ -8965,7 +9579,7 @@
 </file>
 
 <file path=ppt/slides/slide7.xml><?xml version="1.0" encoding="utf-8"?>
-<p:sld xmlns:a="http://schemas.openxmlformats.org/drawingml/2006/main" xmlns:p="http://schemas.openxmlformats.org/presentationml/2006/main" xmlns:r="http://schemas.openxmlformats.org/officeDocument/2006/relationships">
+<p:sld xmlns:a="http://schemas.openxmlformats.org/drawingml/2006/main" xmlns:r="http://schemas.openxmlformats.org/officeDocument/2006/relationships" xmlns:p="http://schemas.openxmlformats.org/presentationml/2006/main">
   <p:cSld>
     <p:bg>
       <p:bgPr>
@@ -8981,7 +9595,14 @@
         <p:cNvGrpSpPr/>
         <p:nvPr/>
       </p:nvGrpSpPr>
-      <p:grpSpPr/>
+      <p:grpSpPr>
+        <a:xfrm>
+          <a:off x="0" y="0"/>
+          <a:ext cx="0" cy="0"/>
+          <a:chOff x="0" y="0"/>
+          <a:chExt cx="0" cy="0"/>
+        </a:xfrm>
+      </p:grpSpPr>
       <p:sp>
         <p:nvSpPr>
           <p:cNvPr id="2" name="Rounded Rectangle 1"/>
@@ -9018,7 +9639,7 @@
           </a:fontRef>
         </p:style>
         <p:txBody>
-          <a:bodyPr rtlCol="0" anchor="ctr" wrap="none" lIns="128016" rIns="128016" tIns="36576" bIns="36576"/>
+          <a:bodyPr wrap="none" lIns="128016" tIns="36576" rIns="128016" bIns="36576" rtlCol="0" anchor="ctr"/>
           <a:lstStyle/>
           <a:p>
             <a:pPr algn="ctr">
@@ -9133,7 +9754,7 @@
           </a:fontRef>
         </p:style>
         <p:txBody>
-          <a:bodyPr rtlCol="0" anchor="ctr" wrap="square" lIns="137160" tIns="137160"/>
+          <a:bodyPr wrap="square" lIns="137160" tIns="137160" rtlCol="0" anchor="ctr"/>
           <a:lstStyle/>
           <a:p>
             <a:pPr algn="ctr">
@@ -9201,7 +9822,7 @@
           </a:fontRef>
         </p:style>
         <p:txBody>
-          <a:bodyPr rtlCol="0" anchor="ctr" wrap="square" lIns="137160" tIns="137160"/>
+          <a:bodyPr wrap="square" lIns="137160" tIns="137160" rtlCol="0" anchor="ctr"/>
           <a:lstStyle/>
           <a:p>
             <a:pPr algn="ctr">
@@ -9240,7 +9861,7 @@
 </file>
 
 <file path=ppt/slides/slide8.xml><?xml version="1.0" encoding="utf-8"?>
-<p:sld xmlns:a="http://schemas.openxmlformats.org/drawingml/2006/main" xmlns:p="http://schemas.openxmlformats.org/presentationml/2006/main" xmlns:r="http://schemas.openxmlformats.org/officeDocument/2006/relationships">
+<p:sld xmlns:a="http://schemas.openxmlformats.org/drawingml/2006/main" xmlns:r="http://schemas.openxmlformats.org/officeDocument/2006/relationships" xmlns:p="http://schemas.openxmlformats.org/presentationml/2006/main">
   <p:cSld>
     <p:bg>
       <p:bgPr>
@@ -9256,7 +9877,14 @@
         <p:cNvGrpSpPr/>
         <p:nvPr/>
       </p:nvGrpSpPr>
-      <p:grpSpPr/>
+      <p:grpSpPr>
+        <a:xfrm>
+          <a:off x="0" y="0"/>
+          <a:ext cx="0" cy="0"/>
+          <a:chOff x="0" y="0"/>
+          <a:chExt cx="0" cy="0"/>
+        </a:xfrm>
+      </p:grpSpPr>
       <p:sp>
         <p:nvSpPr>
           <p:cNvPr id="2" name="Rounded Rectangle 1"/>
@@ -9293,7 +9921,7 @@
           </a:fontRef>
         </p:style>
         <p:txBody>
-          <a:bodyPr rtlCol="0" anchor="ctr" wrap="none" lIns="128016" rIns="128016" tIns="36576" bIns="36576"/>
+          <a:bodyPr wrap="none" lIns="128016" tIns="36576" rIns="128016" bIns="36576" rtlCol="0" anchor="ctr"/>
           <a:lstStyle/>
           <a:p>
             <a:pPr algn="ctr">
@@ -9437,7 +10065,7 @@
           </a:fontRef>
         </p:style>
         <p:txBody>
-          <a:bodyPr rtlCol="0" anchor="ctr" wrap="square" lIns="182880" rIns="182880" tIns="228600"/>
+          <a:bodyPr wrap="square" lIns="182880" tIns="228600" rIns="182880" rtlCol="0" anchor="ctr"/>
           <a:lstStyle/>
           <a:p>
             <a:pPr algn="ctr">
@@ -9449,6 +10077,7 @@
               </a:defRPr>
             </a:pPr>
             <a:r>
+              <a:rPr dirty="0"/>
               <a:t>PHASE 1: DEMAND &amp; GRAPH</a:t>
             </a:r>
           </a:p>
@@ -9462,32 +10091,69 @@
               </a:defRPr>
             </a:pPr>
             <a:r>
+              <a:rPr dirty="0"/>
               <a:t>HYDERABAD ADJACENCY MATRIX</a:t>
             </a:r>
           </a:p>
           <a:p>
-            <a:br/>
-            <a:pPr>
-              <a:defRPr sz="1200">
-                <a:solidFill>
-                  <a:srgbClr val="241C1C"/>
-                </a:solidFill>
-                <a:latin typeface="Inter"/>
-              </a:defRPr>
-            </a:pPr>
-            <a:r>
+            <a:br>
+              <a:rPr dirty="0">
+                <a:solidFill>
+                  <a:schemeClr val="tx1"/>
+                </a:solidFill>
+              </a:rPr>
+            </a:br>
+            <a:r>
+              <a:rPr dirty="0">
+                <a:solidFill>
+                  <a:schemeClr val="tx1"/>
+                </a:solidFill>
+              </a:rPr>
               <a:t>• Central Hub: Main Parcel Warehouse (Begumpet)</a:t>
             </a:r>
-            <a:br/>
-            <a:r>
+            <a:br>
+              <a:rPr dirty="0">
+                <a:solidFill>
+                  <a:schemeClr val="tx1"/>
+                </a:solidFill>
+              </a:rPr>
+            </a:br>
+            <a:r>
+              <a:rPr dirty="0">
+                <a:solidFill>
+                  <a:schemeClr val="tx1"/>
+                </a:solidFill>
+              </a:rPr>
               <a:t>• 35+ Delivery Request Nodes across Hyderabad</a:t>
             </a:r>
-            <a:br/>
-            <a:r>
+            <a:br>
+              <a:rPr dirty="0">
+                <a:solidFill>
+                  <a:schemeClr val="tx1"/>
+                </a:solidFill>
+              </a:rPr>
+            </a:br>
+            <a:r>
+              <a:rPr dirty="0">
+                <a:solidFill>
+                  <a:schemeClr val="tx1"/>
+                </a:solidFill>
+              </a:rPr>
               <a:t>• Vehicle Payload Constraints: Van (100 kg), EV Bike (30 kg)</a:t>
             </a:r>
-            <a:br/>
-            <a:r>
+            <a:br>
+              <a:rPr dirty="0">
+                <a:solidFill>
+                  <a:schemeClr val="tx1"/>
+                </a:solidFill>
+              </a:rPr>
+            </a:br>
+            <a:r>
+              <a:rPr dirty="0">
+                <a:solidFill>
+                  <a:schemeClr val="tx1"/>
+                </a:solidFill>
+              </a:rPr>
               <a:t>• Graph Matrix: Edge weights = road distance + traffic delay</a:t>
             </a:r>
           </a:p>
@@ -9531,7 +10197,7 @@
           </a:fontRef>
         </p:style>
         <p:txBody>
-          <a:bodyPr rtlCol="0" anchor="ctr" wrap="square" lIns="182880" rIns="182880" tIns="228600"/>
+          <a:bodyPr wrap="square" lIns="182880" tIns="228600" rIns="182880" rtlCol="0" anchor="ctr"/>
           <a:lstStyle/>
           <a:p>
             <a:pPr algn="ctr">
@@ -9543,6 +10209,7 @@
               </a:defRPr>
             </a:pPr>
             <a:r>
+              <a:rPr dirty="0"/>
               <a:t>PHASE 2A: CARGO SELECTION</a:t>
             </a:r>
           </a:p>
@@ -9556,32 +10223,69 @@
               </a:defRPr>
             </a:pPr>
             <a:r>
+              <a:rPr dirty="0"/>
               <a:t>0/1 KNAPSACK VS GREEDY</a:t>
             </a:r>
           </a:p>
           <a:p>
-            <a:br/>
-            <a:pPr>
-              <a:defRPr sz="1200">
-                <a:solidFill>
-                  <a:srgbClr val="241C1C"/>
-                </a:solidFill>
-                <a:latin typeface="Inter"/>
-              </a:defRPr>
-            </a:pPr>
-            <a:r>
+            <a:br>
+              <a:rPr dirty="0">
+                <a:solidFill>
+                  <a:schemeClr val="tx1"/>
+                </a:solidFill>
+              </a:rPr>
+            </a:br>
+            <a:r>
+              <a:rPr dirty="0">
+                <a:solidFill>
+                  <a:schemeClr val="tx1"/>
+                </a:solidFill>
+              </a:rPr>
               <a:t>• Run 0/1 Knapsack DP: Fills 100% capacity (Rs. 16,450)</a:t>
             </a:r>
-            <a:br/>
-            <a:r>
+            <a:br>
+              <a:rPr dirty="0">
+                <a:solidFill>
+                  <a:schemeClr val="tx1"/>
+                </a:solidFill>
+              </a:rPr>
+            </a:br>
+            <a:r>
+              <a:rPr dirty="0">
+                <a:solidFill>
+                  <a:schemeClr val="tx1"/>
+                </a:solidFill>
+              </a:rPr>
               <a:t>• Run Profit Density Greedy (p/w): Fast sorting (Rs. 15,200)</a:t>
             </a:r>
-            <a:br/>
-            <a:r>
+            <a:br>
+              <a:rPr dirty="0">
+                <a:solidFill>
+                  <a:schemeClr val="tx1"/>
+                </a:solidFill>
+              </a:rPr>
+            </a:br>
+            <a:r>
+              <a:rPr dirty="0">
+                <a:solidFill>
+                  <a:schemeClr val="tx1"/>
+                </a:solidFill>
+              </a:rPr>
               <a:t>• Run Earliest Deadline First (EDF) for urgent SLAs</a:t>
             </a:r>
-            <a:br/>
-            <a:r>
+            <a:br>
+              <a:rPr dirty="0">
+                <a:solidFill>
+                  <a:schemeClr val="tx1"/>
+                </a:solidFill>
+              </a:rPr>
+            </a:br>
+            <a:r>
+              <a:rPr dirty="0">
+                <a:solidFill>
+                  <a:schemeClr val="tx1"/>
+                </a:solidFill>
+              </a:rPr>
               <a:t>• Evaluate revenue capture and packing efficiency gaps</a:t>
             </a:r>
           </a:p>
@@ -9625,7 +10329,7 @@
           </a:fontRef>
         </p:style>
         <p:txBody>
-          <a:bodyPr rtlCol="0" anchor="ctr" wrap="square" lIns="182880" rIns="182880" tIns="228600"/>
+          <a:bodyPr wrap="square" lIns="182880" tIns="228600" rIns="182880" rtlCol="0" anchor="ctr"/>
           <a:lstStyle/>
           <a:p>
             <a:pPr algn="ctr">
@@ -9637,6 +10341,7 @@
               </a:defRPr>
             </a:pPr>
             <a:r>
+              <a:rPr dirty="0"/>
               <a:t>PHASE 2B: ROUTING SYNTHESIS</a:t>
             </a:r>
           </a:p>
@@ -9650,32 +10355,69 @@
               </a:defRPr>
             </a:pPr>
             <a:r>
+              <a:rPr dirty="0"/>
               <a:t>DIJKSTRA &amp; BELLMAN-FORD</a:t>
             </a:r>
           </a:p>
           <a:p>
-            <a:br/>
-            <a:pPr>
-              <a:defRPr sz="1200">
-                <a:solidFill>
-                  <a:srgbClr val="241C1C"/>
-                </a:solidFill>
-                <a:latin typeface="Inter"/>
-              </a:defRPr>
-            </a:pPr>
-            <a:r>
+            <a:br>
+              <a:rPr dirty="0">
+                <a:solidFill>
+                  <a:schemeClr val="tx1"/>
+                </a:solidFill>
+              </a:rPr>
+            </a:br>
+            <a:r>
+              <a:rPr dirty="0">
+                <a:solidFill>
+                  <a:schemeClr val="tx1"/>
+                </a:solidFill>
+              </a:rPr>
               <a:t>• Dijkstra SSSP via Binary Min-Heap Priority Queue</a:t>
             </a:r>
-            <a:br/>
-            <a:r>
+            <a:br>
+              <a:rPr dirty="0">
+                <a:solidFill>
+                  <a:schemeClr val="tx1"/>
+                </a:solidFill>
+              </a:rPr>
+            </a:br>
+            <a:r>
+              <a:rPr dirty="0">
+                <a:solidFill>
+                  <a:schemeClr val="tx1"/>
+                </a:solidFill>
+              </a:rPr>
               <a:t>• Bellman-Ford audits negative traffic congestion cycles</a:t>
             </a:r>
-            <a:br/>
-            <a:r>
+            <a:br>
+              <a:rPr dirty="0">
+                <a:solidFill>
+                  <a:schemeClr val="tx1"/>
+                </a:solidFill>
+              </a:rPr>
+            </a:br>
+            <a:r>
+              <a:rPr dirty="0">
+                <a:solidFill>
+                  <a:schemeClr val="tx1"/>
+                </a:solidFill>
+              </a:rPr>
               <a:t>• Construct optimal turn-by-turn waypoint sequences</a:t>
             </a:r>
-            <a:br/>
-            <a:r>
+            <a:br>
+              <a:rPr dirty="0">
+                <a:solidFill>
+                  <a:schemeClr val="tx1"/>
+                </a:solidFill>
+              </a:rPr>
+            </a:br>
+            <a:r>
+              <a:rPr dirty="0">
+                <a:solidFill>
+                  <a:schemeClr val="tx1"/>
+                </a:solidFill>
+              </a:rPr>
               <a:t>• Live dispatch telemetry streamed to Google Maps UI</a:t>
             </a:r>
           </a:p>
@@ -9690,7 +10432,7 @@
 </file>
 
 <file path=ppt/slides/slide9.xml><?xml version="1.0" encoding="utf-8"?>
-<p:sld xmlns:a="http://schemas.openxmlformats.org/drawingml/2006/main" xmlns:p="http://schemas.openxmlformats.org/presentationml/2006/main" xmlns:r="http://schemas.openxmlformats.org/officeDocument/2006/relationships">
+<p:sld xmlns:a="http://schemas.openxmlformats.org/drawingml/2006/main" xmlns:r="http://schemas.openxmlformats.org/officeDocument/2006/relationships" xmlns:p="http://schemas.openxmlformats.org/presentationml/2006/main">
   <p:cSld>
     <p:bg>
       <p:bgPr>
@@ -9706,7 +10448,14 @@
         <p:cNvGrpSpPr/>
         <p:nvPr/>
       </p:nvGrpSpPr>
-      <p:grpSpPr/>
+      <p:grpSpPr>
+        <a:xfrm>
+          <a:off x="0" y="0"/>
+          <a:ext cx="0" cy="0"/>
+          <a:chOff x="0" y="0"/>
+          <a:chExt cx="0" cy="0"/>
+        </a:xfrm>
+      </p:grpSpPr>
       <p:sp>
         <p:nvSpPr>
           <p:cNvPr id="2" name="Rounded Rectangle 1"/>
@@ -9743,7 +10492,7 @@
           </a:fontRef>
         </p:style>
         <p:txBody>
-          <a:bodyPr rtlCol="0" anchor="ctr" wrap="none" lIns="128016" rIns="128016" tIns="36576" bIns="36576"/>
+          <a:bodyPr wrap="none" lIns="128016" tIns="36576" rIns="128016" bIns="36576" rtlCol="0" anchor="ctr"/>
           <a:lstStyle/>
           <a:p>
             <a:pPr algn="ctr">
@@ -9834,7 +10583,7 @@
           </a:fontRef>
         </p:style>
         <p:txBody>
-          <a:bodyPr rtlCol="0" anchor="ctr" wrap="square" lIns="182880" rIns="182880" tIns="228600"/>
+          <a:bodyPr wrap="square" lIns="182880" tIns="228600" rIns="182880" rtlCol="0" anchor="ctr"/>
           <a:lstStyle/>
           <a:p>
             <a:pPr algn="ctr">
@@ -9846,6 +10595,7 @@
               </a:defRPr>
             </a:pPr>
             <a:r>
+              <a:rPr dirty="0"/>
               <a:t>01. 0/1 KNAPSACK (DP)</a:t>
             </a:r>
           </a:p>
@@ -9859,45 +10609,233 @@
               </a:defRPr>
             </a:pPr>
             <a:r>
+              <a:rPr dirty="0"/>
               <a:t>BELLMAN RECURRENCE • O(n · W)</a:t>
             </a:r>
           </a:p>
           <a:p>
-            <a:br/>
-            <a:pPr>
-              <a:defRPr sz="1200">
-                <a:solidFill>
-                  <a:srgbClr val="241C1C"/>
-                </a:solidFill>
-                <a:latin typeface="Inter"/>
-              </a:defRPr>
-            </a:pPr>
-            <a:r>
+            <a:br>
+              <a:rPr sz="1600" dirty="0">
+                <a:solidFill>
+                  <a:schemeClr val="tx1"/>
+                </a:solidFill>
+              </a:rPr>
+            </a:br>
+            <a:r>
+              <a:rPr sz="1600" dirty="0">
+                <a:solidFill>
+                  <a:schemeClr val="tx1"/>
+                </a:solidFill>
+              </a:rPr>
               <a:t>Mathematical Formulation:</a:t>
             </a:r>
-            <a:br/>
-            <a:r>
-              <a:t>DP[i][w] = DP[i-1][w]   if w_i &gt; w</a:t>
-            </a:r>
-            <a:br/>
-            <a:r>
-              <a:t>DP[i][w] = max(DP[i-1][w], DP[i-1][w - w_i] + p_i)</a:t>
-            </a:r>
-            <a:br/>
-            <a:br/>
-            <a:r>
+            <a:br>
+              <a:rPr sz="1600" dirty="0">
+                <a:solidFill>
+                  <a:schemeClr val="tx1"/>
+                </a:solidFill>
+              </a:rPr>
+            </a:br>
+            <a:r>
+              <a:rPr sz="1600" dirty="0">
+                <a:solidFill>
+                  <a:schemeClr val="tx1"/>
+                </a:solidFill>
+              </a:rPr>
+              <a:t>DP[</a:t>
+            </a:r>
+            <a:r>
+              <a:rPr sz="1600" dirty="0" err="1">
+                <a:solidFill>
+                  <a:schemeClr val="tx1"/>
+                </a:solidFill>
+              </a:rPr>
+              <a:t>i</a:t>
+            </a:r>
+            <a:r>
+              <a:rPr sz="1600" dirty="0">
+                <a:solidFill>
+                  <a:schemeClr val="tx1"/>
+                </a:solidFill>
+              </a:rPr>
+              <a:t>][w] = DP[i-1][w]   if </a:t>
+            </a:r>
+            <a:r>
+              <a:rPr sz="1600" dirty="0" err="1">
+                <a:solidFill>
+                  <a:schemeClr val="tx1"/>
+                </a:solidFill>
+              </a:rPr>
+              <a:t>w_i</a:t>
+            </a:r>
+            <a:r>
+              <a:rPr sz="1600" dirty="0">
+                <a:solidFill>
+                  <a:schemeClr val="tx1"/>
+                </a:solidFill>
+              </a:rPr>
+              <a:t> &gt; w</a:t>
+            </a:r>
+            <a:br>
+              <a:rPr sz="1600" dirty="0">
+                <a:solidFill>
+                  <a:schemeClr val="tx1"/>
+                </a:solidFill>
+              </a:rPr>
+            </a:br>
+            <a:r>
+              <a:rPr sz="1600" dirty="0">
+                <a:solidFill>
+                  <a:schemeClr val="tx1"/>
+                </a:solidFill>
+              </a:rPr>
+              <a:t>DP[</a:t>
+            </a:r>
+            <a:r>
+              <a:rPr sz="1600" dirty="0" err="1">
+                <a:solidFill>
+                  <a:schemeClr val="tx1"/>
+                </a:solidFill>
+              </a:rPr>
+              <a:t>i</a:t>
+            </a:r>
+            <a:r>
+              <a:rPr sz="1600" dirty="0">
+                <a:solidFill>
+                  <a:schemeClr val="tx1"/>
+                </a:solidFill>
+              </a:rPr>
+              <a:t>][w] = max(DP[i-1][w], DP[i-1][w - </a:t>
+            </a:r>
+            <a:r>
+              <a:rPr sz="1600" dirty="0" err="1">
+                <a:solidFill>
+                  <a:schemeClr val="tx1"/>
+                </a:solidFill>
+              </a:rPr>
+              <a:t>w_i</a:t>
+            </a:r>
+            <a:r>
+              <a:rPr sz="1600" dirty="0">
+                <a:solidFill>
+                  <a:schemeClr val="tx1"/>
+                </a:solidFill>
+              </a:rPr>
+              <a:t>] + </a:t>
+            </a:r>
+            <a:r>
+              <a:rPr sz="1600" dirty="0" err="1">
+                <a:solidFill>
+                  <a:schemeClr val="tx1"/>
+                </a:solidFill>
+              </a:rPr>
+              <a:t>p_i</a:t>
+            </a:r>
+            <a:r>
+              <a:rPr sz="1600" dirty="0">
+                <a:solidFill>
+                  <a:schemeClr val="tx1"/>
+                </a:solidFill>
+              </a:rPr>
+              <a:t>)</a:t>
+            </a:r>
+            <a:br>
+              <a:rPr sz="1600" dirty="0">
+                <a:solidFill>
+                  <a:schemeClr val="tx1"/>
+                </a:solidFill>
+              </a:rPr>
+            </a:br>
+            <a:br>
+              <a:rPr sz="1600" dirty="0">
+                <a:solidFill>
+                  <a:schemeClr val="tx1"/>
+                </a:solidFill>
+              </a:rPr>
+            </a:br>
+            <a:r>
+              <a:rPr sz="1600" dirty="0">
+                <a:solidFill>
+                  <a:schemeClr val="tx1"/>
+                </a:solidFill>
+              </a:rPr>
               <a:t>• Table Dimensions: (N + 1) × (W + 1)</a:t>
             </a:r>
-            <a:br/>
-            <a:r>
-              <a:t>• Cell decision: SKIP (item i excluded) vs TAKE (item i included).</a:t>
-            </a:r>
-            <a:br/>
-            <a:r>
+            <a:br>
+              <a:rPr sz="1600" dirty="0">
+                <a:solidFill>
+                  <a:schemeClr val="tx1"/>
+                </a:solidFill>
+              </a:rPr>
+            </a:br>
+            <a:r>
+              <a:rPr sz="1600" dirty="0">
+                <a:solidFill>
+                  <a:schemeClr val="tx1"/>
+                </a:solidFill>
+              </a:rPr>
+              <a:t>• Cell decision: SKIP (item </a:t>
+            </a:r>
+            <a:r>
+              <a:rPr sz="1600" dirty="0" err="1">
+                <a:solidFill>
+                  <a:schemeClr val="tx1"/>
+                </a:solidFill>
+              </a:rPr>
+              <a:t>i</a:t>
+            </a:r>
+            <a:r>
+              <a:rPr sz="1600" dirty="0">
+                <a:solidFill>
+                  <a:schemeClr val="tx1"/>
+                </a:solidFill>
+              </a:rPr>
+              <a:t> excluded) vs TAKE (item </a:t>
+            </a:r>
+            <a:r>
+              <a:rPr sz="1600" dirty="0" err="1">
+                <a:solidFill>
+                  <a:schemeClr val="tx1"/>
+                </a:solidFill>
+              </a:rPr>
+              <a:t>i</a:t>
+            </a:r>
+            <a:r>
+              <a:rPr sz="1600" dirty="0">
+                <a:solidFill>
+                  <a:schemeClr val="tx1"/>
+                </a:solidFill>
+              </a:rPr>
+              <a:t> included).</a:t>
+            </a:r>
+            <a:br>
+              <a:rPr sz="1600" dirty="0">
+                <a:solidFill>
+                  <a:schemeClr val="tx1"/>
+                </a:solidFill>
+              </a:rPr>
+            </a:br>
+            <a:r>
+              <a:rPr sz="1600" dirty="0">
+                <a:solidFill>
+                  <a:schemeClr val="tx1"/>
+                </a:solidFill>
+              </a:rPr>
               <a:t>• Golden Backtracking: Traces optimal parcel combination.</a:t>
             </a:r>
-            <a:br/>
-            <a:r>
+            <a:br>
+              <a:rPr sz="1600" dirty="0">
+                <a:solidFill>
+                  <a:schemeClr val="tx1"/>
+                </a:solidFill>
+              </a:rPr>
+            </a:br>
+            <a:r>
+              <a:rPr sz="1600" dirty="0">
+                <a:solidFill>
+                  <a:schemeClr val="tx1"/>
+                </a:solidFill>
+              </a:rPr>
               <a:t>• Invariant: Guarantees 100% global revenue capture.</a:t>
             </a:r>
           </a:p>
@@ -9941,7 +10879,7 @@
           </a:fontRef>
         </p:style>
         <p:txBody>
-          <a:bodyPr rtlCol="0" anchor="ctr" wrap="square" lIns="182880" rIns="182880" tIns="228600"/>
+          <a:bodyPr wrap="square" lIns="182880" tIns="228600" rIns="182880" rtlCol="0" anchor="ctr"/>
           <a:lstStyle/>
           <a:p>
             <a:pPr algn="ctr">
@@ -9953,6 +10891,7 @@
               </a:defRPr>
             </a:pPr>
             <a:r>
+              <a:rPr dirty="0"/>
               <a:t>02. PROFIT DENSITY GREEDY</a:t>
             </a:r>
           </a:p>
@@ -9966,37 +10905,139 @@
               </a:defRPr>
             </a:pPr>
             <a:r>
+              <a:rPr dirty="0"/>
               <a:t>DANTZIG RATIO SORT • O(n log n)</a:t>
             </a:r>
           </a:p>
           <a:p>
-            <a:br/>
-            <a:pPr>
-              <a:defRPr sz="1200">
-                <a:solidFill>
-                  <a:srgbClr val="241C1C"/>
-                </a:solidFill>
-                <a:latin typeface="Inter"/>
-              </a:defRPr>
-            </a:pPr>
-            <a:r>
+            <a:br>
+              <a:rPr sz="1600" dirty="0">
+                <a:solidFill>
+                  <a:schemeClr val="tx1"/>
+                </a:solidFill>
+              </a:rPr>
+            </a:br>
+            <a:r>
+              <a:rPr sz="1600" dirty="0">
+                <a:solidFill>
+                  <a:schemeClr val="tx1"/>
+                </a:solidFill>
+              </a:rPr>
               <a:t>Heuristic Formulation:</a:t>
             </a:r>
-            <a:br/>
-            <a:r>
-              <a:t>Calculate ratio r_i = p_i / w_i for each order.</a:t>
-            </a:r>
-            <a:br/>
-            <a:r>
+            <a:br>
+              <a:rPr sz="1600" dirty="0">
+                <a:solidFill>
+                  <a:schemeClr val="tx1"/>
+                </a:solidFill>
+              </a:rPr>
+            </a:br>
+            <a:r>
+              <a:rPr sz="1600" dirty="0">
+                <a:solidFill>
+                  <a:schemeClr val="tx1"/>
+                </a:solidFill>
+              </a:rPr>
+              <a:t>Calculate ratio </a:t>
+            </a:r>
+            <a:r>
+              <a:rPr sz="1600" dirty="0" err="1">
+                <a:solidFill>
+                  <a:schemeClr val="tx1"/>
+                </a:solidFill>
+              </a:rPr>
+              <a:t>r_i</a:t>
+            </a:r>
+            <a:r>
+              <a:rPr sz="1600" dirty="0">
+                <a:solidFill>
+                  <a:schemeClr val="tx1"/>
+                </a:solidFill>
+              </a:rPr>
+              <a:t> = </a:t>
+            </a:r>
+            <a:r>
+              <a:rPr sz="1600" dirty="0" err="1">
+                <a:solidFill>
+                  <a:schemeClr val="tx1"/>
+                </a:solidFill>
+              </a:rPr>
+              <a:t>p_i</a:t>
+            </a:r>
+            <a:r>
+              <a:rPr sz="1600" dirty="0">
+                <a:solidFill>
+                  <a:schemeClr val="tx1"/>
+                </a:solidFill>
+              </a:rPr>
+              <a:t> / </a:t>
+            </a:r>
+            <a:r>
+              <a:rPr sz="1600" dirty="0" err="1">
+                <a:solidFill>
+                  <a:schemeClr val="tx1"/>
+                </a:solidFill>
+              </a:rPr>
+              <a:t>w_i</a:t>
+            </a:r>
+            <a:r>
+              <a:rPr sz="1600" dirty="0">
+                <a:solidFill>
+                  <a:schemeClr val="tx1"/>
+                </a:solidFill>
+              </a:rPr>
+              <a:t> for each order.</a:t>
+            </a:r>
+            <a:br>
+              <a:rPr sz="1600" dirty="0">
+                <a:solidFill>
+                  <a:schemeClr val="tx1"/>
+                </a:solidFill>
+              </a:rPr>
+            </a:br>
+            <a:r>
+              <a:rPr sz="1600" dirty="0">
+                <a:solidFill>
+                  <a:schemeClr val="tx1"/>
+                </a:solidFill>
+              </a:rPr>
               <a:t>Sort in descending order and greedily insert while weight &lt;= W.</a:t>
             </a:r>
-            <a:br/>
-            <a:br/>
-            <a:r>
+            <a:br>
+              <a:rPr sz="1600" dirty="0">
+                <a:solidFill>
+                  <a:schemeClr val="tx1"/>
+                </a:solidFill>
+              </a:rPr>
+            </a:br>
+            <a:br>
+              <a:rPr sz="1600" dirty="0">
+                <a:solidFill>
+                  <a:schemeClr val="tx1"/>
+                </a:solidFill>
+              </a:rPr>
+            </a:br>
+            <a:r>
+              <a:rPr sz="1600" dirty="0">
+                <a:solidFill>
+                  <a:schemeClr val="tx1"/>
+                </a:solidFill>
+              </a:rPr>
               <a:t>• Algorithmic Flaw:</a:t>
             </a:r>
-            <a:br/>
-            <a:r>
+            <a:br>
+              <a:rPr sz="1600" dirty="0">
+                <a:solidFill>
+                  <a:schemeClr val="tx1"/>
+                </a:solidFill>
+              </a:rPr>
+            </a:br>
+            <a:r>
+              <a:rPr sz="1600" dirty="0">
+                <a:solidFill>
+                  <a:schemeClr val="tx1"/>
+                </a:solidFill>
+              </a:rPr>
               <a:t>Greedy choice property guarantees optimality only when items are divisible. For discrete parcels, fractional voids waste valuable payload space.</a:t>
             </a:r>
           </a:p>
@@ -10040,7 +11081,7 @@
           </a:fontRef>
         </p:style>
         <p:txBody>
-          <a:bodyPr rtlCol="0" anchor="ctr" wrap="square" lIns="182880" rIns="182880" tIns="228600"/>
+          <a:bodyPr wrap="square" lIns="182880" tIns="228600" rIns="182880" rtlCol="0" anchor="ctr"/>
           <a:lstStyle/>
           <a:p>
             <a:pPr algn="ctr">
@@ -10052,6 +11093,7 @@
               </a:defRPr>
             </a:pPr>
             <a:r>
+              <a:rPr dirty="0"/>
               <a:t>03. ALTERNATIVE HEURISTICS</a:t>
             </a:r>
           </a:p>
@@ -10065,41 +11107,170 @@
               </a:defRPr>
             </a:pPr>
             <a:r>
+              <a:rPr dirty="0"/>
               <a:t>SLA &amp; BASELINE POLICIES</a:t>
             </a:r>
           </a:p>
           <a:p>
-            <a:br/>
-            <a:pPr>
-              <a:defRPr sz="1200">
-                <a:solidFill>
-                  <a:srgbClr val="241C1C"/>
-                </a:solidFill>
-                <a:latin typeface="Inter"/>
-              </a:defRPr>
-            </a:pPr>
-            <a:r>
+            <a:br>
+              <a:rPr sz="1600" dirty="0">
+                <a:solidFill>
+                  <a:schemeClr val="tx1"/>
+                </a:solidFill>
+              </a:rPr>
+            </a:br>
+            <a:r>
+              <a:rPr sz="1600" dirty="0">
+                <a:solidFill>
+                  <a:schemeClr val="tx1"/>
+                </a:solidFill>
+              </a:rPr>
               <a:t>Comparative Heuristic Strategies:</a:t>
             </a:r>
-            <a:br/>
-            <a:br/>
-            <a:r>
-              <a:t>1. Profit Density: max (p_i / w_i) — 92.4% Optimal.</a:t>
-            </a:r>
-            <a:br/>
-            <a:r>
-              <a:t>2. Highest Profit: max p_i — 83.9% Optimal.</a:t>
-            </a:r>
-            <a:br/>
-            <a:r>
+            <a:br>
+              <a:rPr sz="1600" dirty="0">
+                <a:solidFill>
+                  <a:schemeClr val="tx1"/>
+                </a:solidFill>
+              </a:rPr>
+            </a:br>
+            <a:br>
+              <a:rPr sz="1600" dirty="0">
+                <a:solidFill>
+                  <a:schemeClr val="tx1"/>
+                </a:solidFill>
+              </a:rPr>
+            </a:br>
+            <a:r>
+              <a:rPr sz="1600" dirty="0">
+                <a:solidFill>
+                  <a:schemeClr val="tx1"/>
+                </a:solidFill>
+              </a:rPr>
+              <a:t>1. Profit Density: max (</a:t>
+            </a:r>
+            <a:r>
+              <a:rPr sz="1600" dirty="0" err="1">
+                <a:solidFill>
+                  <a:schemeClr val="tx1"/>
+                </a:solidFill>
+              </a:rPr>
+              <a:t>p_i</a:t>
+            </a:r>
+            <a:r>
+              <a:rPr sz="1600" dirty="0">
+                <a:solidFill>
+                  <a:schemeClr val="tx1"/>
+                </a:solidFill>
+              </a:rPr>
+              <a:t> / </a:t>
+            </a:r>
+            <a:r>
+              <a:rPr sz="1600" dirty="0" err="1">
+                <a:solidFill>
+                  <a:schemeClr val="tx1"/>
+                </a:solidFill>
+              </a:rPr>
+              <a:t>w_i</a:t>
+            </a:r>
+            <a:r>
+              <a:rPr sz="1600" dirty="0">
+                <a:solidFill>
+                  <a:schemeClr val="tx1"/>
+                </a:solidFill>
+              </a:rPr>
+              <a:t>) — 92.4% Optimal.</a:t>
+            </a:r>
+            <a:br>
+              <a:rPr sz="1600" dirty="0">
+                <a:solidFill>
+                  <a:schemeClr val="tx1"/>
+                </a:solidFill>
+              </a:rPr>
+            </a:br>
+            <a:r>
+              <a:rPr sz="1600" dirty="0">
+                <a:solidFill>
+                  <a:schemeClr val="tx1"/>
+                </a:solidFill>
+              </a:rPr>
+              <a:t>2. Highest Profit: max </a:t>
+            </a:r>
+            <a:r>
+              <a:rPr sz="1600" dirty="0" err="1">
+                <a:solidFill>
+                  <a:schemeClr val="tx1"/>
+                </a:solidFill>
+              </a:rPr>
+              <a:t>p_i</a:t>
+            </a:r>
+            <a:r>
+              <a:rPr sz="1600" dirty="0">
+                <a:solidFill>
+                  <a:schemeClr val="tx1"/>
+                </a:solidFill>
+              </a:rPr>
+              <a:t> — 83.9% Optimal.</a:t>
+            </a:r>
+            <a:br>
+              <a:rPr sz="1600" dirty="0">
+                <a:solidFill>
+                  <a:schemeClr val="tx1"/>
+                </a:solidFill>
+              </a:rPr>
+            </a:br>
+            <a:r>
+              <a:rPr sz="1600" dirty="0">
+                <a:solidFill>
+                  <a:schemeClr val="tx1"/>
+                </a:solidFill>
+              </a:rPr>
               <a:t>   Biased toward heavy orders, under-utilizing vehicle volume.</a:t>
             </a:r>
-            <a:br/>
-            <a:r>
-              <a:t>3. Earliest Deadline First (EDF): min d_i — 85.7% Optimal.</a:t>
-            </a:r>
-            <a:br/>
-            <a:r>
+            <a:br>
+              <a:rPr sz="1600" dirty="0">
+                <a:solidFill>
+                  <a:schemeClr val="tx1"/>
+                </a:solidFill>
+              </a:rPr>
+            </a:br>
+            <a:r>
+              <a:rPr sz="1600" dirty="0">
+                <a:solidFill>
+                  <a:schemeClr val="tx1"/>
+                </a:solidFill>
+              </a:rPr>
+              <a:t>3. Earliest Deadline First (EDF): min </a:t>
+            </a:r>
+            <a:r>
+              <a:rPr sz="1600" dirty="0" err="1">
+                <a:solidFill>
+                  <a:schemeClr val="tx1"/>
+                </a:solidFill>
+              </a:rPr>
+              <a:t>d_i</a:t>
+            </a:r>
+            <a:r>
+              <a:rPr sz="1600" dirty="0">
+                <a:solidFill>
+                  <a:schemeClr val="tx1"/>
+                </a:solidFill>
+              </a:rPr>
+              <a:t> — 85.7% Optimal.</a:t>
+            </a:r>
+            <a:br>
+              <a:rPr sz="1600" dirty="0">
+                <a:solidFill>
+                  <a:schemeClr val="tx1"/>
+                </a:solidFill>
+              </a:rPr>
+            </a:br>
+            <a:r>
+              <a:rPr sz="1600" dirty="0">
+                <a:solidFill>
+                  <a:schemeClr val="tx1"/>
+                </a:solidFill>
+              </a:rPr>
               <a:t>   Prioritizes urgent customer SLAs.</a:t>
             </a:r>
           </a:p>

</xml_diff>